<commit_message>
fix: doctor uses warnings for non-critical issues, removes irrelevant PATH check
- Tool binary missing: yellow warning instead of red failure (config still works)
- Python missing: advisory instead of failure (only needed for contextgraph)
- Removed ~/.local/bin PATH check (irrelevant since v0.1.3 npx-only approach)
- Node MCPs show 'configured (npx auto-downloads at runtime)' instead of binary check
- contextgraph bridge: advisory if missing, not failure
- bump to v0.1.5
</commit_message>
<xml_diff>
--- a/F2G-Telco-Stakeholder-Presentation.pptx
+++ b/F2G-Telco-Stakeholder-Presentation.pptx
@@ -17,14 +17,14 @@
     <p:sldId id="264" r:id="rId11"/>
     <p:sldId id="270" r:id="rId12"/>
     <p:sldId id="271" r:id="rId13"/>
-    <p:sldId id="273" r:id="rId23"/>
-    <p:sldId id="274" r:id="rId24"/>
-    <p:sldId id="275" r:id="rId25"/>
-    <p:sldId id="272" r:id="rId14"/>
-    <p:sldId id="265" r:id="rId15"/>
-    <p:sldId id="266" r:id="rId16"/>
-    <p:sldId id="267" r:id="rId17"/>
-    <p:sldId id="268" r:id="rId18"/>
+    <p:sldId id="273" r:id="rId14"/>
+    <p:sldId id="274" r:id="rId15"/>
+    <p:sldId id="275" r:id="rId16"/>
+    <p:sldId id="272" r:id="rId17"/>
+    <p:sldId id="265" r:id="rId18"/>
+    <p:sldId id="266" r:id="rId19"/>
+    <p:sldId id="267" r:id="rId20"/>
+    <p:sldId id="268" r:id="rId21"/>
   </p:sldIdLst>
   <p:sldSz cx="12192000" cy="6858000"/>
   <p:notesSz cx="6858000" cy="9144000"/>
@@ -4729,7 +4729,7 @@
               </a:defRPr>
             </a:pPr>
             <a:r>
-              <a:t>Seamless Updates — Like a Play Store</a:t>
+              <a:t>Why This Matters for the F2G-Telco Team</a:t>
             </a:r>
           </a:p>
         </p:txBody>
@@ -4743,7 +4743,7 @@
         <p:spPr>
           <a:xfrm>
             <a:off x="731520" y="1097280"/>
-            <a:ext cx="10058400" cy="4572000"/>
+            <a:ext cx="5486400" cy="457200"/>
           </a:xfrm>
           <a:prstGeom prst="rect">
             <a:avLst/>
@@ -4756,6 +4756,42 @@
           </a:bodyPr>
           <a:lstStyle/>
           <a:p>
+            <a:pPr algn="l">
+              <a:defRPr sz="1900" b="1">
+                <a:solidFill>
+                  <a:srgbClr val="202020"/>
+                </a:solidFill>
+                <a:latin typeface="Calibri"/>
+              </a:defRPr>
+            </a:pPr>
+            <a:r>
+              <a:t>One shared AI brain across every team member:</a:t>
+            </a:r>
+          </a:p>
+        </p:txBody>
+      </p:sp>
+      <p:sp>
+        <p:nvSpPr>
+          <p:cNvPr id="4" name="TextBox 3"/>
+          <p:cNvSpPr txBox="1"/>
+          <p:nvPr/>
+        </p:nvSpPr>
+        <p:spPr>
+          <a:xfrm>
+            <a:off x="731520" y="1737360"/>
+            <a:ext cx="5486400" cy="4572000"/>
+          </a:xfrm>
+          <a:prstGeom prst="rect">
+            <a:avLst/>
+          </a:prstGeom>
+          <a:noFill/>
+        </p:spPr>
+        <p:txBody>
+          <a:bodyPr wrap="square">
+            <a:spAutoFit/>
+          </a:bodyPr>
+          <a:lstStyle/>
+          <a:p>
             <a:pPr>
               <a:spcAft>
                 <a:spcPts val="800"/>
@@ -4768,7 +4804,7 @@
               </a:defRPr>
             </a:pPr>
             <a:r>
-              <a:t>When we publish a new version to npm:</a:t>
+              <a:t>🧠  Global context — what one developer learns, every AI instance knows</a:t>
             </a:r>
           </a:p>
           <a:p>
@@ -4783,7 +4819,9 @@
                 <a:latin typeface="Calibri"/>
               </a:defRPr>
             </a:pPr>
-            <a:endParaRPr/>
+            <a:r>
+              <a:t>🔄  No repeated explanations — onboard a new member, the AI already has the history</a:t>
+            </a:r>
           </a:p>
           <a:p>
             <a:pPr>
@@ -4798,7 +4836,7 @@
               </a:defRPr>
             </a:pPr>
             <a:r>
-              <a:t>$ npx f2g-telco update</a:t>
+              <a:t>🤝  Seamless handoffs — Dev A starts a task, Dev B picks it up with full context</a:t>
             </a:r>
           </a:p>
           <a:p>
@@ -4813,7 +4851,9 @@
                 <a:latin typeface="Calibri"/>
               </a:defRPr>
             </a:pPr>
-            <a:endParaRPr/>
+            <a:r>
+              <a:t>📈  Compound knowledge — every fix, every decision, every insight accumulates</a:t>
+            </a:r>
           </a:p>
           <a:p>
             <a:pPr>
@@ -4828,7 +4868,7 @@
               </a:defRPr>
             </a:pPr>
             <a:r>
-              <a:t>What happens:</a:t>
+              <a:t>⚡  Faster debugging — AI recalls past solutions across the whole team's experience</a:t>
             </a:r>
           </a:p>
           <a:p>
@@ -4844,7 +4884,7 @@
               </a:defRPr>
             </a:pPr>
             <a:r>
-              <a:t>     • Pulls the latest MCP registry (new servers, updated versions)</a:t>
+              <a:t>🏗️  Consistent architecture — AI enforces the same patterns team-wide</a:t>
             </a:r>
           </a:p>
           <a:p>
@@ -4860,151 +4900,35 @@
               </a:defRPr>
             </a:pPr>
             <a:r>
-              <a:t>     • Pulls the latest provider registry (new models, new providers)</a:t>
-            </a:r>
-          </a:p>
-          <a:p>
-            <a:pPr>
-              <a:spcAft>
-                <a:spcPts val="800"/>
-              </a:spcAft>
-              <a:defRPr sz="1600">
-                <a:solidFill>
-                  <a:srgbClr val="202020"/>
-                </a:solidFill>
-                <a:latin typeface="Calibri"/>
-              </a:defRPr>
-            </a:pPr>
-            <a:r>
-              <a:t>     • Pulls the latest skill sources (new agents, new instructions)</a:t>
-            </a:r>
-          </a:p>
-          <a:p>
-            <a:pPr>
-              <a:spcAft>
-                <a:spcPts val="800"/>
-              </a:spcAft>
-              <a:defRPr sz="1600">
-                <a:solidFill>
-                  <a:srgbClr val="202020"/>
-                </a:solidFill>
-                <a:latin typeface="Calibri"/>
-              </a:defRPr>
-            </a:pPr>
-            <a:r>
-              <a:t>     • Refreshes local configs without losing user's API keys</a:t>
-            </a:r>
-          </a:p>
-          <a:p>
-            <a:pPr>
-              <a:spcAft>
-                <a:spcPts val="800"/>
-              </a:spcAft>
-              <a:defRPr sz="1600">
-                <a:solidFill>
-                  <a:srgbClr val="202020"/>
-                </a:solidFill>
-                <a:latin typeface="Calibri"/>
-              </a:defRPr>
-            </a:pPr>
-            <a:endParaRPr/>
-          </a:p>
-          <a:p>
-            <a:pPr>
-              <a:spcAft>
-                <a:spcPts val="800"/>
-              </a:spcAft>
-              <a:defRPr sz="1600">
-                <a:solidFill>
-                  <a:srgbClr val="202020"/>
-                </a:solidFill>
-                <a:latin typeface="Calibri"/>
-              </a:defRPr>
-            </a:pPr>
-            <a:r>
-              <a:t>Users don't need to:</a:t>
-            </a:r>
-          </a:p>
-          <a:p>
-            <a:pPr>
-              <a:spcAft>
-                <a:spcPts val="800"/>
-              </a:spcAft>
-              <a:defRPr sz="1600">
-                <a:solidFill>
-                  <a:srgbClr val="202020"/>
-                </a:solidFill>
-                <a:latin typeface="Calibri"/>
-              </a:defRPr>
-            </a:pPr>
-            <a:r>
-              <a:t>     ❌  Reinstall anything</a:t>
-            </a:r>
-          </a:p>
-          <a:p>
-            <a:pPr>
-              <a:spcAft>
-                <a:spcPts val="800"/>
-              </a:spcAft>
-              <a:defRPr sz="1600">
-                <a:solidFill>
-                  <a:srgbClr val="202020"/>
-                </a:solidFill>
-                <a:latin typeface="Calibri"/>
-              </a:defRPr>
-            </a:pPr>
-            <a:r>
-              <a:t>     ❌  Re-enter their API keys</a:t>
-            </a:r>
-          </a:p>
-          <a:p>
-            <a:pPr>
-              <a:spcAft>
-                <a:spcPts val="800"/>
-              </a:spcAft>
-              <a:defRPr sz="1600">
-                <a:solidFill>
-                  <a:srgbClr val="202020"/>
-                </a:solidFill>
-                <a:latin typeface="Calibri"/>
-              </a:defRPr>
-            </a:pPr>
-            <a:r>
-              <a:t>     ❌  Manually edit config files</a:t>
-            </a:r>
-          </a:p>
-          <a:p>
-            <a:pPr>
-              <a:spcAft>
-                <a:spcPts val="800"/>
-              </a:spcAft>
-              <a:defRPr sz="1600">
-                <a:solidFill>
-                  <a:srgbClr val="202020"/>
-                </a:solidFill>
-                <a:latin typeface="Calibri"/>
-              </a:defRPr>
-            </a:pPr>
-            <a:endParaRPr/>
-          </a:p>
-          <a:p>
-            <a:pPr>
-              <a:spcAft>
-                <a:spcPts val="800"/>
-              </a:spcAft>
-              <a:defRPr sz="1600">
-                <a:solidFill>
-                  <a:srgbClr val="202020"/>
-                </a:solidFill>
-                <a:latin typeface="Calibri"/>
-              </a:defRPr>
-            </a:pPr>
-            <a:r>
-              <a:t>They just run one command and they're on the latest.</a:t>
-            </a:r>
-          </a:p>
-        </p:txBody>
-      </p:sp>
+              <a:t>🔒  Each member still owns their own API keys and local setup</a:t>
+            </a:r>
+          </a:p>
+        </p:txBody>
+      </p:sp>
+      <p:pic>
+        <p:nvPicPr>
+          <p:cNvPr id="5" name="Picture 4" descr="team-scenario.png"/>
+          <p:cNvPicPr>
+            <a:picLocks noChangeAspect="1"/>
+          </p:cNvPicPr>
+          <p:nvPr/>
+        </p:nvPicPr>
+        <p:blipFill>
+          <a:blip r:embed="rId2"/>
+          <a:stretch>
+            <a:fillRect/>
+          </a:stretch>
+        </p:blipFill>
+        <p:spPr>
+          <a:xfrm>
+            <a:off x="6400800" y="1188720"/>
+            <a:ext cx="5486400" cy="2168013"/>
+          </a:xfrm>
+          <a:prstGeom prst="rect">
+            <a:avLst/>
+          </a:prstGeom>
+        </p:spPr>
+      </p:pic>
     </p:spTree>
   </p:cSld>
   <p:clrMapOvr>
@@ -5069,7 +4993,7 @@
               </a:defRPr>
             </a:pPr>
             <a:r>
-              <a:t>Technical Details</a:t>
+              <a:t>Real Scenario: Shared Context in Action</a:t>
             </a:r>
           </a:p>
         </p:txBody>
@@ -5082,8 +5006,8 @@
         </p:nvSpPr>
         <p:spPr>
           <a:xfrm>
-            <a:off x="731520" y="1188720"/>
-            <a:ext cx="10058400" cy="3657600"/>
+            <a:off x="731520" y="1097280"/>
+            <a:ext cx="10058400" cy="4572000"/>
           </a:xfrm>
           <a:prstGeom prst="rect">
             <a:avLst/>
@@ -5100,159 +5024,249 @@
               <a:spcAft>
                 <a:spcPts val="800"/>
               </a:spcAft>
-              <a:defRPr sz="1700">
-                <a:solidFill>
-                  <a:srgbClr val="202020"/>
-                </a:solidFill>
-                <a:latin typeface="Calibri"/>
-              </a:defRPr>
-            </a:pPr>
-            <a:r>
-              <a:t>Language: TypeScript (compiled to ESM)</a:t>
-            </a:r>
-          </a:p>
-          <a:p>
-            <a:pPr>
-              <a:spcAft>
-                <a:spcPts val="800"/>
-              </a:spcAft>
-              <a:defRPr sz="1700">
-                <a:solidFill>
-                  <a:srgbClr val="202020"/>
-                </a:solidFill>
-                <a:latin typeface="Calibri"/>
-              </a:defRPr>
-            </a:pPr>
-            <a:r>
-              <a:t>License: MIT</a:t>
-            </a:r>
-          </a:p>
-          <a:p>
-            <a:pPr>
-              <a:spcAft>
-                <a:spcPts val="800"/>
-              </a:spcAft>
-              <a:defRPr sz="1700">
-                <a:solidFill>
-                  <a:srgbClr val="202020"/>
-                </a:solidFill>
-                <a:latin typeface="Calibri"/>
-              </a:defRPr>
-            </a:pPr>
-            <a:r>
-              <a:t>Node: 18+ required</a:t>
-            </a:r>
-          </a:p>
-          <a:p>
-            <a:pPr>
-              <a:spcAft>
-                <a:spcPts val="800"/>
-              </a:spcAft>
-              <a:defRPr sz="1700">
-                <a:solidFill>
-                  <a:srgbClr val="202020"/>
-                </a:solidFill>
-                <a:latin typeface="Calibri"/>
-              </a:defRPr>
-            </a:pPr>
-            <a:r>
-              <a:t>Distribution: npm (npx f2g-telco init — zero global install)</a:t>
-            </a:r>
-          </a:p>
-          <a:p>
-            <a:pPr>
-              <a:spcAft>
-                <a:spcPts val="800"/>
-              </a:spcAft>
-              <a:defRPr sz="1700">
-                <a:solidFill>
-                  <a:srgbClr val="202020"/>
-                </a:solidFill>
-                <a:latin typeface="Calibri"/>
-              </a:defRPr>
-            </a:pPr>
-            <a:r>
-              <a:t>CI: GitHub Actions on Node 18, 20, 22</a:t>
-            </a:r>
-          </a:p>
-          <a:p>
-            <a:pPr>
-              <a:spcAft>
-                <a:spcPts val="800"/>
-              </a:spcAft>
-              <a:defRPr sz="1700">
-                <a:solidFill>
-                  <a:srgbClr val="202020"/>
-                </a:solidFill>
-                <a:latin typeface="Calibri"/>
-              </a:defRPr>
-            </a:pPr>
-            <a:r>
-              <a:t>Tests: 13 test cases covering registry, config generation, CLI commands</a:t>
-            </a:r>
-          </a:p>
-          <a:p>
-            <a:pPr>
-              <a:spcAft>
-                <a:spcPts val="800"/>
-              </a:spcAft>
-              <a:defRPr sz="1700">
-                <a:solidFill>
-                  <a:srgbClr val="202020"/>
-                </a:solidFill>
-                <a:latin typeface="Calibri"/>
-              </a:defRPr>
-            </a:pPr>
-            <a:r>
-              <a:t>Registry: JSON files (mcps.json, providers.json, skills.json) — easy to extend</a:t>
-            </a:r>
-          </a:p>
-          <a:p>
-            <a:pPr>
-              <a:spcAft>
-                <a:spcPts val="800"/>
-              </a:spcAft>
-              <a:defRPr sz="1700">
-                <a:solidFill>
-                  <a:srgbClr val="202020"/>
-                </a:solidFill>
-                <a:latin typeface="Calibri"/>
-              </a:defRPr>
-            </a:pPr>
-            <a:r>
-              <a:t>Logging: All commands log to ~/.f2g-telco/f2g-telco.log</a:t>
-            </a:r>
-          </a:p>
-          <a:p>
-            <a:pPr>
-              <a:spcAft>
-                <a:spcPts val="800"/>
-              </a:spcAft>
-              <a:defRPr sz="1700">
-                <a:solidFill>
-                  <a:srgbClr val="202020"/>
-                </a:solidFill>
-                <a:latin typeface="Calibri"/>
-              </a:defRPr>
-            </a:pPr>
-            <a:r>
-              <a:t>Error handling: Ctrl+C safe, --verbose flag for debugging</a:t>
-            </a:r>
-          </a:p>
-          <a:p>
-            <a:pPr>
-              <a:spcAft>
-                <a:spcPts val="800"/>
-              </a:spcAft>
-              <a:defRPr sz="1700">
-                <a:solidFill>
-                  <a:srgbClr val="202020"/>
-                </a:solidFill>
-                <a:latin typeface="Calibri"/>
-              </a:defRPr>
-            </a:pPr>
-            <a:r>
-              <a:t>Repo: github.com/suzannekouemou/f2g-telco</a:t>
+              <a:defRPr sz="1600">
+                <a:solidFill>
+                  <a:srgbClr val="202020"/>
+                </a:solidFill>
+                <a:latin typeface="Calibri"/>
+              </a:defRPr>
+            </a:pPr>
+            <a:r>
+              <a:t>Monday morning — Developer A (using Kiro):</a:t>
+            </a:r>
+          </a:p>
+          <a:p>
+            <a:pPr>
+              <a:spcAft>
+                <a:spcPts val="800"/>
+              </a:spcAft>
+              <a:defRPr sz="1600">
+                <a:solidFill>
+                  <a:srgbClr val="202020"/>
+                </a:solidFill>
+                <a:latin typeface="Calibri"/>
+              </a:defRPr>
+            </a:pPr>
+            <a:r>
+              <a:t>     → Fixes a critical bug in the payment module</a:t>
+            </a:r>
+          </a:p>
+          <a:p>
+            <a:pPr>
+              <a:spcAft>
+                <a:spcPts val="800"/>
+              </a:spcAft>
+              <a:defRPr sz="1600">
+                <a:solidFill>
+                  <a:srgbClr val="202020"/>
+                </a:solidFill>
+                <a:latin typeface="Calibri"/>
+              </a:defRPr>
+            </a:pPr>
+            <a:r>
+              <a:t>     → AI stores: "Root cause was race condition in transaction queue"</a:t>
+            </a:r>
+          </a:p>
+          <a:p>
+            <a:pPr>
+              <a:spcAft>
+                <a:spcPts val="800"/>
+              </a:spcAft>
+              <a:defRPr sz="1600">
+                <a:solidFill>
+                  <a:srgbClr val="202020"/>
+                </a:solidFill>
+                <a:latin typeface="Calibri"/>
+              </a:defRPr>
+            </a:pPr>
+            <a:endParaRPr/>
+          </a:p>
+          <a:p>
+            <a:pPr>
+              <a:spcAft>
+                <a:spcPts val="800"/>
+              </a:spcAft>
+              <a:defRPr sz="1600">
+                <a:solidFill>
+                  <a:srgbClr val="202020"/>
+                </a:solidFill>
+                <a:latin typeface="Calibri"/>
+              </a:defRPr>
+            </a:pPr>
+            <a:r>
+              <a:t>Monday afternoon — Developer B (using Crush):</a:t>
+            </a:r>
+          </a:p>
+          <a:p>
+            <a:pPr>
+              <a:spcAft>
+                <a:spcPts val="800"/>
+              </a:spcAft>
+              <a:defRPr sz="1600">
+                <a:solidFill>
+                  <a:srgbClr val="202020"/>
+                </a:solidFill>
+                <a:latin typeface="Calibri"/>
+              </a:defRPr>
+            </a:pPr>
+            <a:r>
+              <a:t>     → Starts working on the same module</a:t>
+            </a:r>
+          </a:p>
+          <a:p>
+            <a:pPr>
+              <a:spcAft>
+                <a:spcPts val="800"/>
+              </a:spcAft>
+              <a:defRPr sz="1600">
+                <a:solidFill>
+                  <a:srgbClr val="202020"/>
+                </a:solidFill>
+                <a:latin typeface="Calibri"/>
+              </a:defRPr>
+            </a:pPr>
+            <a:r>
+              <a:t>     → AI recalls A's fix automatically — no Slack message needed</a:t>
+            </a:r>
+          </a:p>
+          <a:p>
+            <a:pPr>
+              <a:spcAft>
+                <a:spcPts val="800"/>
+              </a:spcAft>
+              <a:defRPr sz="1600">
+                <a:solidFill>
+                  <a:srgbClr val="202020"/>
+                </a:solidFill>
+                <a:latin typeface="Calibri"/>
+              </a:defRPr>
+            </a:pPr>
+            <a:r>
+              <a:t>     → Builds on top of it instead of duplicating effort</a:t>
+            </a:r>
+          </a:p>
+          <a:p>
+            <a:pPr>
+              <a:spcAft>
+                <a:spcPts val="800"/>
+              </a:spcAft>
+              <a:defRPr sz="1600">
+                <a:solidFill>
+                  <a:srgbClr val="202020"/>
+                </a:solidFill>
+                <a:latin typeface="Calibri"/>
+              </a:defRPr>
+            </a:pPr>
+            <a:endParaRPr/>
+          </a:p>
+          <a:p>
+            <a:pPr>
+              <a:spcAft>
+                <a:spcPts val="800"/>
+              </a:spcAft>
+              <a:defRPr sz="1600">
+                <a:solidFill>
+                  <a:srgbClr val="202020"/>
+                </a:solidFill>
+                <a:latin typeface="Calibri"/>
+              </a:defRPr>
+            </a:pPr>
+            <a:r>
+              <a:t>Tuesday — Developer C (new team member):</a:t>
+            </a:r>
+          </a:p>
+          <a:p>
+            <a:pPr>
+              <a:spcAft>
+                <a:spcPts val="800"/>
+              </a:spcAft>
+              <a:defRPr sz="1600">
+                <a:solidFill>
+                  <a:srgbClr val="202020"/>
+                </a:solidFill>
+                <a:latin typeface="Calibri"/>
+              </a:defRPr>
+            </a:pPr>
+            <a:r>
+              <a:t>     → Runs npx f2g-telco init — full environment in 5 minutes</a:t>
+            </a:r>
+          </a:p>
+          <a:p>
+            <a:pPr>
+              <a:spcAft>
+                <a:spcPts val="800"/>
+              </a:spcAft>
+              <a:defRPr sz="1600">
+                <a:solidFill>
+                  <a:srgbClr val="202020"/>
+                </a:solidFill>
+                <a:latin typeface="Calibri"/>
+              </a:defRPr>
+            </a:pPr>
+            <a:r>
+              <a:t>     → AI already knows the entire team's history</a:t>
+            </a:r>
+          </a:p>
+          <a:p>
+            <a:pPr>
+              <a:spcAft>
+                <a:spcPts val="800"/>
+              </a:spcAft>
+              <a:defRPr sz="1600">
+                <a:solidFill>
+                  <a:srgbClr val="202020"/>
+                </a:solidFill>
+                <a:latin typeface="Calibri"/>
+              </a:defRPr>
+            </a:pPr>
+            <a:r>
+              <a:t>     → Productive from day one, not week two</a:t>
+            </a:r>
+          </a:p>
+          <a:p>
+            <a:pPr>
+              <a:spcAft>
+                <a:spcPts val="800"/>
+              </a:spcAft>
+              <a:defRPr sz="1600">
+                <a:solidFill>
+                  <a:srgbClr val="202020"/>
+                </a:solidFill>
+                <a:latin typeface="Calibri"/>
+              </a:defRPr>
+            </a:pPr>
+            <a:endParaRPr/>
+          </a:p>
+          <a:p>
+            <a:pPr>
+              <a:spcAft>
+                <a:spcPts val="800"/>
+              </a:spcAft>
+              <a:defRPr sz="1600" b="1">
+                <a:solidFill>
+                  <a:srgbClr val="0D9453"/>
+                </a:solidFill>
+                <a:latin typeface="Calibri"/>
+              </a:defRPr>
+            </a:pPr>
+            <a:r>
+              <a:t>The AI becomes the team's institutional memory.</a:t>
+            </a:r>
+          </a:p>
+          <a:p>
+            <a:pPr>
+              <a:spcAft>
+                <a:spcPts val="800"/>
+              </a:spcAft>
+              <a:defRPr sz="1600" b="1">
+                <a:solidFill>
+                  <a:srgbClr val="0D9453"/>
+                </a:solidFill>
+                <a:latin typeface="Calibri"/>
+              </a:defRPr>
+            </a:pPr>
+            <a:r>
+              <a:t>No one has to write handoff docs. No context is ever lost.</a:t>
             </a:r>
           </a:p>
         </p:txBody>
@@ -5321,21 +5335,67 @@
               </a:defRPr>
             </a:pPr>
             <a:r>
-              <a:t>Live Demo Flow</a:t>
-            </a:r>
-          </a:p>
-        </p:txBody>
-      </p:sp>
-      <p:sp>
-        <p:nvSpPr>
-          <p:cNvPr id="3" name="TextBox 2"/>
+              <a:t>How We Enable Shared Context</a:t>
+            </a:r>
+          </a:p>
+        </p:txBody>
+      </p:sp>
+      <p:sp>
+        <p:nvSpPr>
+          <p:cNvPr id="3" name="Rounded Rectangle 2"/>
+          <p:cNvSpPr/>
+          <p:nvPr/>
+        </p:nvSpPr>
+        <p:spPr>
+          <a:xfrm>
+            <a:off x="731520" y="1188720"/>
+            <a:ext cx="5029200" cy="4572000"/>
+          </a:xfrm>
+          <a:prstGeom prst="roundRect">
+            <a:avLst/>
+          </a:prstGeom>
+          <a:solidFill>
+            <a:srgbClr val="F8F9FA"/>
+          </a:solidFill>
+          <a:ln w="25400">
+            <a:solidFill>
+              <a:srgbClr val="1A73E8"/>
+            </a:solidFill>
+          </a:ln>
+        </p:spPr>
+        <p:style>
+          <a:lnRef idx="1">
+            <a:schemeClr val="accent1"/>
+          </a:lnRef>
+          <a:fillRef idx="3">
+            <a:schemeClr val="accent1"/>
+          </a:fillRef>
+          <a:effectRef idx="2">
+            <a:schemeClr val="accent1"/>
+          </a:effectRef>
+          <a:fontRef idx="minor">
+            <a:schemeClr val="lt1"/>
+          </a:fontRef>
+        </p:style>
+        <p:txBody>
+          <a:bodyPr rtlCol="0" anchor="ctr"/>
+          <a:lstStyle/>
+          <a:p>
+            <a:pPr algn="ctr"/>
+            <a:endParaRPr/>
+          </a:p>
+        </p:txBody>
+      </p:sp>
+      <p:sp>
+        <p:nvSpPr>
+          <p:cNvPr id="4" name="TextBox 3"/>
           <p:cNvSpPr txBox="1"/>
           <p:nvPr/>
         </p:nvSpPr>
         <p:spPr>
           <a:xfrm>
-            <a:off x="1371600" y="1097280"/>
-            <a:ext cx="9144000" cy="5303520"/>
+            <a:off x="1097280" y="1371600"/>
+            <a:ext cx="4389120" cy="457200"/>
           </a:xfrm>
           <a:prstGeom prst="rect">
             <a:avLst/>
@@ -5348,303 +5408,432 @@
           </a:bodyPr>
           <a:lstStyle/>
           <a:p>
-            <a:pPr>
-              <a:defRPr sz="1400" b="1">
+            <a:pPr algn="l">
+              <a:defRPr sz="2000" b="1">
+                <a:solidFill>
+                  <a:srgbClr val="0D9453"/>
+                </a:solidFill>
+                <a:latin typeface="Calibri"/>
+              </a:defRPr>
+            </a:pPr>
+            <a:r>
+              <a:t>✅ Already Possible Today</a:t>
+            </a:r>
+          </a:p>
+        </p:txBody>
+      </p:sp>
+      <p:sp>
+        <p:nvSpPr>
+          <p:cNvPr id="5" name="TextBox 4"/>
+          <p:cNvSpPr txBox="1"/>
+          <p:nvPr/>
+        </p:nvSpPr>
+        <p:spPr>
+          <a:xfrm>
+            <a:off x="1097280" y="2103120"/>
+            <a:ext cx="4389120" cy="4572000"/>
+          </a:xfrm>
+          <a:prstGeom prst="rect">
+            <a:avLst/>
+          </a:prstGeom>
+          <a:noFill/>
+        </p:spPr>
+        <p:txBody>
+          <a:bodyPr wrap="square">
+            <a:spAutoFit/>
+          </a:bodyPr>
+          <a:lstStyle/>
+          <a:p>
+            <a:pPr>
+              <a:spcAft>
+                <a:spcPts val="800"/>
+              </a:spcAft>
+              <a:defRPr sz="1500">
+                <a:solidFill>
+                  <a:srgbClr val="202020"/>
+                </a:solidFill>
+                <a:latin typeface="Calibri"/>
+              </a:defRPr>
+            </a:pPr>
+            <a:r>
+              <a:t>• Create a shared mem0 API key</a:t>
+            </a:r>
+          </a:p>
+          <a:p>
+            <a:pPr>
+              <a:spcAft>
+                <a:spcPts val="800"/>
+              </a:spcAft>
+              <a:defRPr sz="1500">
+                <a:solidFill>
+                  <a:srgbClr val="202020"/>
+                </a:solidFill>
+                <a:latin typeface="Calibri"/>
+              </a:defRPr>
+            </a:pPr>
+            <a:r>
+              <a:t>• F2G-Telco configures it for all members</a:t>
+            </a:r>
+          </a:p>
+          <a:p>
+            <a:pPr>
+              <a:spcAft>
+                <a:spcPts val="800"/>
+              </a:spcAft>
+              <a:defRPr sz="1500">
+                <a:solidFill>
+                  <a:srgbClr val="202020"/>
+                </a:solidFill>
+                <a:latin typeface="Calibri"/>
+              </a:defRPr>
+            </a:pPr>
+            <a:r>
+              <a:t>• All AI instances read/write to same memory</a:t>
+            </a:r>
+          </a:p>
+          <a:p>
+            <a:pPr>
+              <a:spcAft>
+                <a:spcPts val="800"/>
+              </a:spcAft>
+              <a:defRPr sz="1500">
+                <a:solidFill>
+                  <a:srgbClr val="202020"/>
+                </a:solidFill>
+                <a:latin typeface="Calibri"/>
+              </a:defRPr>
+            </a:pPr>
+            <a:r>
+              <a:t>• ContextGraph hydrates from shared mem0</a:t>
+            </a:r>
+          </a:p>
+          <a:p>
+            <a:pPr>
+              <a:spcAft>
+                <a:spcPts val="800"/>
+              </a:spcAft>
+              <a:defRPr sz="1500">
+                <a:solidFill>
+                  <a:srgbClr val="202020"/>
+                </a:solidFill>
+                <a:latin typeface="Calibri"/>
+              </a:defRPr>
+            </a:pPr>
+            <a:r>
+              <a:t>• Works across Kiro AND Crush</a:t>
+            </a:r>
+          </a:p>
+          <a:p>
+            <a:pPr>
+              <a:spcAft>
+                <a:spcPts val="800"/>
+              </a:spcAft>
+              <a:defRPr sz="1500">
+                <a:solidFill>
+                  <a:srgbClr val="202020"/>
+                </a:solidFill>
+                <a:latin typeface="Calibri"/>
+              </a:defRPr>
+            </a:pPr>
+            <a:endParaRPr/>
+          </a:p>
+          <a:p>
+            <a:pPr>
+              <a:spcAft>
+                <a:spcPts val="800"/>
+              </a:spcAft>
+              <a:defRPr sz="1500">
+                <a:solidFill>
+                  <a:srgbClr val="202020"/>
+                </a:solidFill>
+                <a:latin typeface="Calibri"/>
+              </a:defRPr>
+            </a:pPr>
+            <a:r>
+              <a:t>Zero code changes needed.</a:t>
+            </a:r>
+          </a:p>
+          <a:p>
+            <a:pPr>
+              <a:spcAft>
+                <a:spcPts val="800"/>
+              </a:spcAft>
+              <a:defRPr sz="1500">
+                <a:solidFill>
+                  <a:srgbClr val="202020"/>
+                </a:solidFill>
+                <a:latin typeface="Calibri"/>
+              </a:defRPr>
+            </a:pPr>
+            <a:r>
+              <a:t>Just one shared key in the config.</a:t>
+            </a:r>
+          </a:p>
+        </p:txBody>
+      </p:sp>
+      <p:sp>
+        <p:nvSpPr>
+          <p:cNvPr id="6" name="Rounded Rectangle 5"/>
+          <p:cNvSpPr/>
+          <p:nvPr/>
+        </p:nvSpPr>
+        <p:spPr>
+          <a:xfrm>
+            <a:off x="6400800" y="1188720"/>
+            <a:ext cx="5029200" cy="4572000"/>
+          </a:xfrm>
+          <a:prstGeom prst="roundRect">
+            <a:avLst/>
+          </a:prstGeom>
+          <a:solidFill>
+            <a:srgbClr val="F8F9FA"/>
+          </a:solidFill>
+          <a:ln w="25400">
+            <a:solidFill>
+              <a:srgbClr val="1A73E8"/>
+            </a:solidFill>
+          </a:ln>
+        </p:spPr>
+        <p:style>
+          <a:lnRef idx="1">
+            <a:schemeClr val="accent1"/>
+          </a:lnRef>
+          <a:fillRef idx="3">
+            <a:schemeClr val="accent1"/>
+          </a:fillRef>
+          <a:effectRef idx="2">
+            <a:schemeClr val="accent1"/>
+          </a:effectRef>
+          <a:fontRef idx="minor">
+            <a:schemeClr val="lt1"/>
+          </a:fontRef>
+        </p:style>
+        <p:txBody>
+          <a:bodyPr rtlCol="0" anchor="ctr"/>
+          <a:lstStyle/>
+          <a:p>
+            <a:pPr algn="ctr"/>
+            <a:endParaRPr/>
+          </a:p>
+        </p:txBody>
+      </p:sp>
+      <p:sp>
+        <p:nvSpPr>
+          <p:cNvPr id="7" name="TextBox 6"/>
+          <p:cNvSpPr txBox="1"/>
+          <p:nvPr/>
+        </p:nvSpPr>
+        <p:spPr>
+          <a:xfrm>
+            <a:off x="6766560" y="1371600"/>
+            <a:ext cx="4389120" cy="457200"/>
+          </a:xfrm>
+          <a:prstGeom prst="rect">
+            <a:avLst/>
+          </a:prstGeom>
+          <a:noFill/>
+        </p:spPr>
+        <p:txBody>
+          <a:bodyPr wrap="square">
+            <a:spAutoFit/>
+          </a:bodyPr>
+          <a:lstStyle/>
+          <a:p>
+            <a:pPr algn="l">
+              <a:defRPr sz="2000" b="1">
                 <a:solidFill>
                   <a:srgbClr val="1A73E8"/>
                 </a:solidFill>
-                <a:latin typeface="Consolas"/>
-              </a:defRPr>
-            </a:pPr>
-            <a:r>
-              <a:t>$ npx f2g-telco init</a:t>
-            </a:r>
-          </a:p>
-          <a:p>
-            <a:pPr>
-              <a:defRPr sz="1400">
-                <a:solidFill>
-                  <a:srgbClr val="202020"/>
-                </a:solidFill>
-                <a:latin typeface="Consolas"/>
+                <a:latin typeface="Calibri"/>
+              </a:defRPr>
+            </a:pPr>
+            <a:r>
+              <a:t>🔜 Coming Next</a:t>
+            </a:r>
+          </a:p>
+        </p:txBody>
+      </p:sp>
+      <p:sp>
+        <p:nvSpPr>
+          <p:cNvPr id="8" name="TextBox 7"/>
+          <p:cNvSpPr txBox="1"/>
+          <p:nvPr/>
+        </p:nvSpPr>
+        <p:spPr>
+          <a:xfrm>
+            <a:off x="6766560" y="2103120"/>
+            <a:ext cx="4389120" cy="4572000"/>
+          </a:xfrm>
+          <a:prstGeom prst="rect">
+            <a:avLst/>
+          </a:prstGeom>
+          <a:noFill/>
+        </p:spPr>
+        <p:txBody>
+          <a:bodyPr wrap="square">
+            <a:spAutoFit/>
+          </a:bodyPr>
+          <a:lstStyle/>
+          <a:p>
+            <a:pPr>
+              <a:spcAft>
+                <a:spcPts val="800"/>
+              </a:spcAft>
+              <a:defRPr sz="1500">
+                <a:solidFill>
+                  <a:srgbClr val="202020"/>
+                </a:solidFill>
+                <a:latin typeface="Calibri"/>
+              </a:defRPr>
+            </a:pPr>
+            <a:r>
+              <a:t>• Team profiles in F2G-Telco CLI</a:t>
+            </a:r>
+          </a:p>
+          <a:p>
+            <a:pPr>
+              <a:spcAft>
+                <a:spcPts val="800"/>
+              </a:spcAft>
+              <a:defRPr sz="1500">
+                <a:solidFill>
+                  <a:srgbClr val="202020"/>
+                </a:solidFill>
+                <a:latin typeface="Calibri"/>
+              </a:defRPr>
+            </a:pPr>
+            <a:r>
+              <a:t>• f2g-telco init --team &lt;name&gt;</a:t>
+            </a:r>
+          </a:p>
+          <a:p>
+            <a:pPr>
+              <a:spcAft>
+                <a:spcPts val="800"/>
+              </a:spcAft>
+              <a:defRPr sz="1500">
+                <a:solidFill>
+                  <a:srgbClr val="202020"/>
+                </a:solidFill>
+                <a:latin typeface="Calibri"/>
+              </a:defRPr>
+            </a:pPr>
+            <a:r>
+              <a:t>• Pre-configured shared keys</a:t>
+            </a:r>
+          </a:p>
+          <a:p>
+            <a:pPr>
+              <a:spcAft>
+                <a:spcPts val="800"/>
+              </a:spcAft>
+              <a:defRPr sz="1500">
+                <a:solidFill>
+                  <a:srgbClr val="202020"/>
+                </a:solidFill>
+                <a:latin typeface="Calibri"/>
+              </a:defRPr>
+            </a:pPr>
+            <a:r>
+              <a:t>• Role-based context visibility</a:t>
+            </a:r>
+          </a:p>
+          <a:p>
+            <a:pPr>
+              <a:spcAft>
+                <a:spcPts val="800"/>
+              </a:spcAft>
+              <a:defRPr sz="1500">
+                <a:solidFill>
+                  <a:srgbClr val="202020"/>
+                </a:solidFill>
+                <a:latin typeface="Calibri"/>
+              </a:defRPr>
+            </a:pPr>
+            <a:r>
+              <a:t>• Admin dashboard for team memory</a:t>
+            </a:r>
+          </a:p>
+          <a:p>
+            <a:pPr>
+              <a:spcAft>
+                <a:spcPts val="800"/>
+              </a:spcAft>
+              <a:defRPr sz="1500">
+                <a:solidFill>
+                  <a:srgbClr val="202020"/>
+                </a:solidFill>
+                <a:latin typeface="Calibri"/>
               </a:defRPr>
             </a:pPr>
             <a:endParaRPr/>
           </a:p>
           <a:p>
             <a:pPr>
-              <a:defRPr sz="1400">
-                <a:solidFill>
-                  <a:srgbClr val="202020"/>
-                </a:solidFill>
-                <a:latin typeface="Consolas"/>
-              </a:defRPr>
-            </a:pPr>
-            <a:r>
-              <a:t>  Step 1/5  Detecting AI tools...</a:t>
-            </a:r>
-          </a:p>
-          <a:p>
-            <a:pPr>
-              <a:defRPr sz="1400">
-                <a:solidFill>
-                  <a:srgbClr val="0D9453"/>
-                </a:solidFill>
-                <a:latin typeface="Consolas"/>
-              </a:defRPr>
-            </a:pPr>
-            <a:r>
-              <a:t>  ✔ Crush v0.51.3 detected</a:t>
-            </a:r>
-          </a:p>
-          <a:p>
-            <a:pPr>
-              <a:defRPr sz="1400">
-                <a:solidFill>
-                  <a:srgbClr val="202020"/>
-                </a:solidFill>
-                <a:latin typeface="Consolas"/>
-              </a:defRPr>
-            </a:pPr>
-            <a:endParaRPr/>
-          </a:p>
-          <a:p>
-            <a:pPr>
-              <a:defRPr sz="1400">
-                <a:solidFill>
-                  <a:srgbClr val="202020"/>
-                </a:solidFill>
-                <a:latin typeface="Consolas"/>
-              </a:defRPr>
-            </a:pPr>
-            <a:r>
-              <a:t>  Step 2/5  Select providers:</a:t>
-            </a:r>
-          </a:p>
-          <a:p>
-            <a:pPr>
-              <a:defRPr sz="1400">
-                <a:solidFill>
-                  <a:srgbClr val="0D9453"/>
-                </a:solidFill>
-                <a:latin typeface="Consolas"/>
-              </a:defRPr>
-            </a:pPr>
-            <a:r>
-              <a:t>  ✔ GitHub Copilot (already authenticated)</a:t>
-            </a:r>
-          </a:p>
-          <a:p>
-            <a:pPr>
-              <a:defRPr sz="1400">
-                <a:solidFill>
-                  <a:srgbClr val="0D9453"/>
-                </a:solidFill>
-                <a:latin typeface="Consolas"/>
-              </a:defRPr>
-            </a:pPr>
-            <a:r>
-              <a:t>  ✔ NVIDIA NIM (key entered)</a:t>
-            </a:r>
-          </a:p>
-          <a:p>
-            <a:pPr>
-              <a:defRPr sz="1400">
+              <a:spcAft>
+                <a:spcPts val="800"/>
+              </a:spcAft>
+              <a:defRPr sz="1500">
+                <a:solidFill>
+                  <a:srgbClr val="202020"/>
+                </a:solidFill>
+                <a:latin typeface="Calibri"/>
+              </a:defRPr>
+            </a:pPr>
+            <a:r>
+              <a:t>One command to join the team's</a:t>
+            </a:r>
+          </a:p>
+          <a:p>
+            <a:pPr>
+              <a:spcAft>
+                <a:spcPts val="800"/>
+              </a:spcAft>
+              <a:defRPr sz="1500">
+                <a:solidFill>
+                  <a:srgbClr val="202020"/>
+                </a:solidFill>
+                <a:latin typeface="Calibri"/>
+              </a:defRPr>
+            </a:pPr>
+            <a:r>
+              <a:t>AI knowledge network.</a:t>
+            </a:r>
+          </a:p>
+        </p:txBody>
+      </p:sp>
+      <p:sp>
+        <p:nvSpPr>
+          <p:cNvPr id="9" name="TextBox 8"/>
+          <p:cNvSpPr txBox="1"/>
+          <p:nvPr/>
+        </p:nvSpPr>
+        <p:spPr>
+          <a:xfrm>
+            <a:off x="731520" y="5943600"/>
+            <a:ext cx="10058400" cy="457200"/>
+          </a:xfrm>
+          <a:prstGeom prst="rect">
+            <a:avLst/>
+          </a:prstGeom>
+          <a:noFill/>
+        </p:spPr>
+        <p:txBody>
+          <a:bodyPr wrap="square">
+            <a:spAutoFit/>
+          </a:bodyPr>
+          <a:lstStyle/>
+          <a:p>
+            <a:pPr algn="l">
+              <a:defRPr sz="1600" b="1">
                 <a:solidFill>
                   <a:srgbClr val="5F6368"/>
                 </a:solidFill>
-                <a:latin typeface="Consolas"/>
-              </a:defRPr>
-            </a:pPr>
-            <a:r>
-              <a:t>  ⊘ Groq (skipped)</a:t>
-            </a:r>
-          </a:p>
-          <a:p>
-            <a:pPr>
-              <a:defRPr sz="1400">
-                <a:solidFill>
-                  <a:srgbClr val="202020"/>
-                </a:solidFill>
-                <a:latin typeface="Consolas"/>
-              </a:defRPr>
-            </a:pPr>
-            <a:endParaRPr/>
-          </a:p>
-          <a:p>
-            <a:pPr>
-              <a:defRPr sz="1400">
-                <a:solidFill>
-                  <a:srgbClr val="202020"/>
-                </a:solidFill>
-                <a:latin typeface="Consolas"/>
-              </a:defRPr>
-            </a:pPr>
-            <a:r>
-              <a:t>  Step 3/5  Configuring MCP servers...</a:t>
-            </a:r>
-          </a:p>
-          <a:p>
-            <a:pPr>
-              <a:defRPr sz="1400">
-                <a:solidFill>
-                  <a:srgbClr val="0D9453"/>
-                </a:solidFill>
-                <a:latin typeface="Consolas"/>
-              </a:defRPr>
-            </a:pPr>
-            <a:r>
-              <a:t>  ✔ mem0 configured (via npx)</a:t>
-            </a:r>
-          </a:p>
-          <a:p>
-            <a:pPr>
-              <a:defRPr sz="1400">
-                <a:solidFill>
-                  <a:srgbClr val="0D9453"/>
-                </a:solidFill>
-                <a:latin typeface="Consolas"/>
-              </a:defRPr>
-            </a:pPr>
-            <a:r>
-              <a:t>  ✔ context7 configured (via npx)</a:t>
-            </a:r>
-          </a:p>
-          <a:p>
-            <a:pPr>
-              <a:defRPr sz="1400">
-                <a:solidFill>
-                  <a:srgbClr val="0D9453"/>
-                </a:solidFill>
-                <a:latin typeface="Consolas"/>
-              </a:defRPr>
-            </a:pPr>
-            <a:r>
-              <a:t>  ✔ contextgraph installed</a:t>
-            </a:r>
-          </a:p>
-          <a:p>
-            <a:pPr>
-              <a:defRPr sz="1400">
-                <a:solidFill>
-                  <a:srgbClr val="202020"/>
-                </a:solidFill>
-                <a:latin typeface="Consolas"/>
-              </a:defRPr>
-            </a:pPr>
-            <a:r>
-              <a:t>  ... 10 more ...</a:t>
-            </a:r>
-          </a:p>
-          <a:p>
-            <a:pPr>
-              <a:defRPr sz="1400">
-                <a:solidFill>
-                  <a:srgbClr val="202020"/>
-                </a:solidFill>
-                <a:latin typeface="Consolas"/>
-              </a:defRPr>
-            </a:pPr>
-            <a:endParaRPr/>
-          </a:p>
-          <a:p>
-            <a:pPr>
-              <a:defRPr sz="1400">
-                <a:solidFill>
-                  <a:srgbClr val="202020"/>
-                </a:solidFill>
-                <a:latin typeface="Consolas"/>
-              </a:defRPr>
-            </a:pPr>
-            <a:r>
-              <a:t>  Step 4/5  Installing skills...</a:t>
-            </a:r>
-          </a:p>
-          <a:p>
-            <a:pPr>
-              <a:defRPr sz="1400">
-                <a:solidFill>
-                  <a:srgbClr val="0D9453"/>
-                </a:solidFill>
-                <a:latin typeface="Consolas"/>
-              </a:defRPr>
-            </a:pPr>
-            <a:r>
-              <a:t>  ✔ awesome-copilot (16 agents, 16 skills)</a:t>
-            </a:r>
-          </a:p>
-          <a:p>
-            <a:pPr>
-              <a:defRPr sz="1400">
-                <a:solidFill>
-                  <a:srgbClr val="202020"/>
-                </a:solidFill>
-                <a:latin typeface="Consolas"/>
-              </a:defRPr>
-            </a:pPr>
-            <a:endParaRPr/>
-          </a:p>
-          <a:p>
-            <a:pPr>
-              <a:defRPr sz="1400">
-                <a:solidFill>
-                  <a:srgbClr val="202020"/>
-                </a:solidFill>
-                <a:latin typeface="Consolas"/>
-              </a:defRPr>
-            </a:pPr>
-            <a:r>
-              <a:t>  Step 5/5  Writing configs...</a:t>
-            </a:r>
-          </a:p>
-          <a:p>
-            <a:pPr>
-              <a:defRPr sz="1400">
-                <a:solidFill>
-                  <a:srgbClr val="0D9453"/>
-                </a:solidFill>
-                <a:latin typeface="Consolas"/>
-              </a:defRPr>
-            </a:pPr>
-            <a:r>
-              <a:t>  ✔ crush.json written</a:t>
-            </a:r>
-          </a:p>
-          <a:p>
-            <a:pPr>
-              <a:defRPr sz="1400">
-                <a:solidFill>
-                  <a:srgbClr val="0D9453"/>
-                </a:solidFill>
-                <a:latin typeface="Consolas"/>
-              </a:defRPr>
-            </a:pPr>
-            <a:r>
-              <a:t>  ✔ INVENTORY.md generated</a:t>
-            </a:r>
-          </a:p>
-          <a:p>
-            <a:pPr>
-              <a:defRPr sz="1400">
-                <a:solidFill>
-                  <a:srgbClr val="202020"/>
-                </a:solidFill>
-                <a:latin typeface="Consolas"/>
-              </a:defRPr>
-            </a:pPr>
-            <a:endParaRPr/>
-          </a:p>
-          <a:p>
-            <a:pPr>
-              <a:defRPr sz="1400">
-                <a:solidFill>
-                  <a:srgbClr val="202020"/>
-                </a:solidFill>
-                <a:latin typeface="Consolas"/>
-              </a:defRPr>
-            </a:pPr>
-            <a:r>
-              <a:t>  🎉 Done! Restart your terminal and start coding.</a:t>
+                <a:latin typeface="Calibri"/>
+              </a:defRPr>
+            </a:pPr>
+            <a:r>
+              <a:t>The infrastructure is ready. The shared context vision is a configuration change, not a rebuild.</a:t>
             </a:r>
           </a:p>
         </p:txBody>
@@ -5713,7 +5902,7 @@
               </a:defRPr>
             </a:pPr>
             <a:r>
-              <a:t>Roadmap &amp; Next Steps</a:t>
+              <a:t>Seamless Updates — Like a Play Store</a:t>
             </a:r>
           </a:p>
         </p:txBody>
@@ -5726,8 +5915,8 @@
         </p:nvSpPr>
         <p:spPr>
           <a:xfrm>
-            <a:off x="731520" y="1188720"/>
-            <a:ext cx="10058400" cy="3657600"/>
+            <a:off x="731520" y="1097280"/>
+            <a:ext cx="10058400" cy="4572000"/>
           </a:xfrm>
           <a:prstGeom prst="rect">
             <a:avLst/>
@@ -5744,23 +5933,23 @@
               <a:spcAft>
                 <a:spcPts val="800"/>
               </a:spcAft>
-              <a:defRPr sz="1700">
-                <a:solidFill>
-                  <a:srgbClr val="202020"/>
-                </a:solidFill>
-                <a:latin typeface="Calibri"/>
-              </a:defRPr>
-            </a:pPr>
-            <a:r>
-              <a:t>✅  v0.1.3 — Published on npm, 13 MCPs, 7 providers, 3 skill sources</a:t>
-            </a:r>
-          </a:p>
-          <a:p>
-            <a:pPr>
-              <a:spcAft>
-                <a:spcPts val="800"/>
-              </a:spcAft>
-              <a:defRPr sz="1700">
+              <a:defRPr sz="1600">
+                <a:solidFill>
+                  <a:srgbClr val="202020"/>
+                </a:solidFill>
+                <a:latin typeface="Calibri"/>
+              </a:defRPr>
+            </a:pPr>
+            <a:r>
+              <a:t>When we publish a new version to npm:</a:t>
+            </a:r>
+          </a:p>
+          <a:p>
+            <a:pPr>
+              <a:spcAft>
+                <a:spcPts val="800"/>
+              </a:spcAft>
+              <a:defRPr sz="1600">
                 <a:solidFill>
                   <a:srgbClr val="202020"/>
                 </a:solidFill>
@@ -5774,71 +5963,23 @@
               <a:spcAft>
                 <a:spcPts val="800"/>
               </a:spcAft>
-              <a:defRPr sz="1700">
-                <a:solidFill>
-                  <a:srgbClr val="202020"/>
-                </a:solidFill>
-                <a:latin typeface="Calibri"/>
-              </a:defRPr>
-            </a:pPr>
-            <a:r>
-              <a:t>🔜  v0.2.0 — Planned</a:t>
-            </a:r>
-          </a:p>
-          <a:p>
-            <a:pPr>
-              <a:spcAft>
-                <a:spcPts val="800"/>
-              </a:spcAft>
-              <a:defRPr sz="1700">
-                <a:solidFill>
-                  <a:srgbClr val="202020"/>
-                </a:solidFill>
-                <a:latin typeface="Calibri"/>
-              </a:defRPr>
-            </a:pPr>
-            <a:r>
-              <a:t>     • f2g-telco update — pull latest registries, refresh configs</a:t>
-            </a:r>
-          </a:p>
-          <a:p>
-            <a:pPr>
-              <a:spcAft>
-                <a:spcPts val="800"/>
-              </a:spcAft>
-              <a:defRPr sz="1700">
-                <a:solidFill>
-                  <a:srgbClr val="202020"/>
-                </a:solidFill>
-                <a:latin typeface="Calibri"/>
-              </a:defRPr>
-            </a:pPr>
-            <a:r>
-              <a:t>     • f2g-telco doctor — deeper health checks (MCP connectivity, model availability)</a:t>
-            </a:r>
-          </a:p>
-          <a:p>
-            <a:pPr>
-              <a:spcAft>
-                <a:spcPts val="800"/>
-              </a:spcAft>
-              <a:defRPr sz="1700">
-                <a:solidFill>
-                  <a:srgbClr val="202020"/>
-                </a:solidFill>
-                <a:latin typeface="Calibri"/>
-              </a:defRPr>
-            </a:pPr>
-            <a:r>
-              <a:t>     • More skill sources from the community</a:t>
-            </a:r>
-          </a:p>
-          <a:p>
-            <a:pPr>
-              <a:spcAft>
-                <a:spcPts val="800"/>
-              </a:spcAft>
-              <a:defRPr sz="1700">
+              <a:defRPr sz="1600">
+                <a:solidFill>
+                  <a:srgbClr val="202020"/>
+                </a:solidFill>
+                <a:latin typeface="Calibri"/>
+              </a:defRPr>
+            </a:pPr>
+            <a:r>
+              <a:t>$ npx f2g-telco update</a:t>
+            </a:r>
+          </a:p>
+          <a:p>
+            <a:pPr>
+              <a:spcAft>
+                <a:spcPts val="800"/>
+              </a:spcAft>
+              <a:defRPr sz="1600">
                 <a:solidFill>
                   <a:srgbClr val="202020"/>
                 </a:solidFill>
@@ -5852,79 +5993,187 @@
               <a:spcAft>
                 <a:spcPts val="800"/>
               </a:spcAft>
-              <a:defRPr sz="1700">
-                <a:solidFill>
-                  <a:srgbClr val="202020"/>
-                </a:solidFill>
-                <a:latin typeface="Calibri"/>
-              </a:defRPr>
-            </a:pPr>
-            <a:r>
-              <a:t>🔮  Future</a:t>
-            </a:r>
-          </a:p>
-          <a:p>
-            <a:pPr>
-              <a:spcAft>
-                <a:spcPts val="800"/>
-              </a:spcAft>
-              <a:defRPr sz="1700">
-                <a:solidFill>
-                  <a:srgbClr val="202020"/>
-                </a:solidFill>
-                <a:latin typeface="Calibri"/>
-              </a:defRPr>
-            </a:pPr>
-            <a:r>
-              <a:t>     • Team profiles — share configs across an organization</a:t>
-            </a:r>
-          </a:p>
-          <a:p>
-            <a:pPr>
-              <a:spcAft>
-                <a:spcPts val="800"/>
-              </a:spcAft>
-              <a:defRPr sz="1700">
-                <a:solidFill>
-                  <a:srgbClr val="202020"/>
-                </a:solidFill>
-                <a:latin typeface="Calibri"/>
-              </a:defRPr>
-            </a:pPr>
-            <a:r>
-              <a:t>     • Plugin system — third-party MCP registries</a:t>
-            </a:r>
-          </a:p>
-          <a:p>
-            <a:pPr>
-              <a:spcAft>
-                <a:spcPts val="800"/>
-              </a:spcAft>
-              <a:defRPr sz="1700">
-                <a:solidFill>
-                  <a:srgbClr val="202020"/>
-                </a:solidFill>
-                <a:latin typeface="Calibri"/>
-              </a:defRPr>
-            </a:pPr>
-            <a:r>
-              <a:t>     • VS Code / Cursor extension integration</a:t>
-            </a:r>
-          </a:p>
-          <a:p>
-            <a:pPr>
-              <a:spcAft>
-                <a:spcPts val="800"/>
-              </a:spcAft>
-              <a:defRPr sz="1700">
-                <a:solidFill>
-                  <a:srgbClr val="202020"/>
-                </a:solidFill>
-                <a:latin typeface="Calibri"/>
-              </a:defRPr>
-            </a:pPr>
-            <a:r>
-              <a:t>     • Telemetry-free usage analytics (opt-in)</a:t>
+              <a:defRPr sz="1600">
+                <a:solidFill>
+                  <a:srgbClr val="202020"/>
+                </a:solidFill>
+                <a:latin typeface="Calibri"/>
+              </a:defRPr>
+            </a:pPr>
+            <a:r>
+              <a:t>What happens:</a:t>
+            </a:r>
+          </a:p>
+          <a:p>
+            <a:pPr>
+              <a:spcAft>
+                <a:spcPts val="800"/>
+              </a:spcAft>
+              <a:defRPr sz="1600">
+                <a:solidFill>
+                  <a:srgbClr val="202020"/>
+                </a:solidFill>
+                <a:latin typeface="Calibri"/>
+              </a:defRPr>
+            </a:pPr>
+            <a:r>
+              <a:t>     • Pulls the latest MCP registry (new servers, updated versions)</a:t>
+            </a:r>
+          </a:p>
+          <a:p>
+            <a:pPr>
+              <a:spcAft>
+                <a:spcPts val="800"/>
+              </a:spcAft>
+              <a:defRPr sz="1600">
+                <a:solidFill>
+                  <a:srgbClr val="202020"/>
+                </a:solidFill>
+                <a:latin typeface="Calibri"/>
+              </a:defRPr>
+            </a:pPr>
+            <a:r>
+              <a:t>     • Pulls the latest provider registry (new models, new providers)</a:t>
+            </a:r>
+          </a:p>
+          <a:p>
+            <a:pPr>
+              <a:spcAft>
+                <a:spcPts val="800"/>
+              </a:spcAft>
+              <a:defRPr sz="1600">
+                <a:solidFill>
+                  <a:srgbClr val="202020"/>
+                </a:solidFill>
+                <a:latin typeface="Calibri"/>
+              </a:defRPr>
+            </a:pPr>
+            <a:r>
+              <a:t>     • Pulls the latest skill sources (new agents, new instructions)</a:t>
+            </a:r>
+          </a:p>
+          <a:p>
+            <a:pPr>
+              <a:spcAft>
+                <a:spcPts val="800"/>
+              </a:spcAft>
+              <a:defRPr sz="1600">
+                <a:solidFill>
+                  <a:srgbClr val="202020"/>
+                </a:solidFill>
+                <a:latin typeface="Calibri"/>
+              </a:defRPr>
+            </a:pPr>
+            <a:r>
+              <a:t>     • Refreshes local configs without losing user's API keys</a:t>
+            </a:r>
+          </a:p>
+          <a:p>
+            <a:pPr>
+              <a:spcAft>
+                <a:spcPts val="800"/>
+              </a:spcAft>
+              <a:defRPr sz="1600">
+                <a:solidFill>
+                  <a:srgbClr val="202020"/>
+                </a:solidFill>
+                <a:latin typeface="Calibri"/>
+              </a:defRPr>
+            </a:pPr>
+            <a:endParaRPr/>
+          </a:p>
+          <a:p>
+            <a:pPr>
+              <a:spcAft>
+                <a:spcPts val="800"/>
+              </a:spcAft>
+              <a:defRPr sz="1600">
+                <a:solidFill>
+                  <a:srgbClr val="202020"/>
+                </a:solidFill>
+                <a:latin typeface="Calibri"/>
+              </a:defRPr>
+            </a:pPr>
+            <a:r>
+              <a:t>Users don't need to:</a:t>
+            </a:r>
+          </a:p>
+          <a:p>
+            <a:pPr>
+              <a:spcAft>
+                <a:spcPts val="800"/>
+              </a:spcAft>
+              <a:defRPr sz="1600">
+                <a:solidFill>
+                  <a:srgbClr val="202020"/>
+                </a:solidFill>
+                <a:latin typeface="Calibri"/>
+              </a:defRPr>
+            </a:pPr>
+            <a:r>
+              <a:t>     ❌  Reinstall anything</a:t>
+            </a:r>
+          </a:p>
+          <a:p>
+            <a:pPr>
+              <a:spcAft>
+                <a:spcPts val="800"/>
+              </a:spcAft>
+              <a:defRPr sz="1600">
+                <a:solidFill>
+                  <a:srgbClr val="202020"/>
+                </a:solidFill>
+                <a:latin typeface="Calibri"/>
+              </a:defRPr>
+            </a:pPr>
+            <a:r>
+              <a:t>     ❌  Re-enter their API keys</a:t>
+            </a:r>
+          </a:p>
+          <a:p>
+            <a:pPr>
+              <a:spcAft>
+                <a:spcPts val="800"/>
+              </a:spcAft>
+              <a:defRPr sz="1600">
+                <a:solidFill>
+                  <a:srgbClr val="202020"/>
+                </a:solidFill>
+                <a:latin typeface="Calibri"/>
+              </a:defRPr>
+            </a:pPr>
+            <a:r>
+              <a:t>     ❌  Manually edit config files</a:t>
+            </a:r>
+          </a:p>
+          <a:p>
+            <a:pPr>
+              <a:spcAft>
+                <a:spcPts val="800"/>
+              </a:spcAft>
+              <a:defRPr sz="1600">
+                <a:solidFill>
+                  <a:srgbClr val="202020"/>
+                </a:solidFill>
+                <a:latin typeface="Calibri"/>
+              </a:defRPr>
+            </a:pPr>
+            <a:endParaRPr/>
+          </a:p>
+          <a:p>
+            <a:pPr>
+              <a:spcAft>
+                <a:spcPts val="800"/>
+              </a:spcAft>
+              <a:defRPr sz="1600">
+                <a:solidFill>
+                  <a:srgbClr val="202020"/>
+                </a:solidFill>
+                <a:latin typeface="Calibri"/>
+              </a:defRPr>
+            </a:pPr>
+            <a:r>
+              <a:t>They just run one command and they're on the latest.</a:t>
             </a:r>
           </a:p>
         </p:txBody>
@@ -5964,58 +6213,14 @@
       </p:grpSpPr>
       <p:sp>
         <p:nvSpPr>
-          <p:cNvPr id="2" name="Rectangle 1"/>
-          <p:cNvSpPr/>
+          <p:cNvPr id="2" name="TextBox 1"/>
+          <p:cNvSpPr txBox="1"/>
           <p:nvPr/>
         </p:nvSpPr>
         <p:spPr>
           <a:xfrm>
-            <a:off x="0" y="6720840"/>
-            <a:ext cx="12191695" cy="137160"/>
-          </a:xfrm>
-          <a:prstGeom prst="rect">
-            <a:avLst/>
-          </a:prstGeom>
-          <a:solidFill>
-            <a:srgbClr val="1A73E8"/>
-          </a:solidFill>
-          <a:ln>
-            <a:noFill/>
-          </a:ln>
-        </p:spPr>
-        <p:style>
-          <a:lnRef idx="1">
-            <a:schemeClr val="accent1"/>
-          </a:lnRef>
-          <a:fillRef idx="3">
-            <a:schemeClr val="accent1"/>
-          </a:fillRef>
-          <a:effectRef idx="2">
-            <a:schemeClr val="accent1"/>
-          </a:effectRef>
-          <a:fontRef idx="minor">
-            <a:schemeClr val="lt1"/>
-          </a:fontRef>
-        </p:style>
-        <p:txBody>
-          <a:bodyPr rtlCol="0" anchor="ctr"/>
-          <a:lstStyle/>
-          <a:p>
-            <a:pPr algn="ctr"/>
-            <a:endParaRPr/>
-          </a:p>
-        </p:txBody>
-      </p:sp>
-      <p:sp>
-        <p:nvSpPr>
-          <p:cNvPr id="3" name="TextBox 2"/>
-          <p:cNvSpPr txBox="1"/>
-          <p:nvPr/>
-        </p:nvSpPr>
-        <p:spPr>
-          <a:xfrm>
-            <a:off x="1371600" y="2011680"/>
-            <a:ext cx="9144000" cy="914400"/>
+            <a:off x="731520" y="365760"/>
+            <a:ext cx="10058400" cy="640080"/>
           </a:xfrm>
           <a:prstGeom prst="rect">
             <a:avLst/>
@@ -6028,8 +6233,8 @@
           </a:bodyPr>
           <a:lstStyle/>
           <a:p>
-            <a:pPr algn="ctr">
-              <a:defRPr sz="4800" b="1">
+            <a:pPr algn="l">
+              <a:defRPr sz="3200" b="1">
                 <a:solidFill>
                   <a:srgbClr val="1A73E8"/>
                 </a:solidFill>
@@ -6037,21 +6242,21 @@
               </a:defRPr>
             </a:pPr>
             <a:r>
-              <a:t>F2G-Telco</a:t>
-            </a:r>
-          </a:p>
-        </p:txBody>
-      </p:sp>
-      <p:sp>
-        <p:nvSpPr>
-          <p:cNvPr id="4" name="TextBox 3"/>
+              <a:t>Technical Details</a:t>
+            </a:r>
+          </a:p>
+        </p:txBody>
+      </p:sp>
+      <p:sp>
+        <p:nvSpPr>
+          <p:cNvPr id="3" name="TextBox 2"/>
           <p:cNvSpPr txBox="1"/>
           <p:nvPr/>
         </p:nvSpPr>
         <p:spPr>
           <a:xfrm>
-            <a:off x="1371600" y="3108960"/>
-            <a:ext cx="9144000" cy="640080"/>
+            <a:off x="731520" y="1188720"/>
+            <a:ext cx="10058400" cy="3657600"/>
           </a:xfrm>
           <a:prstGeom prst="rect">
             <a:avLst/>
@@ -6064,124 +6269,163 @@
           </a:bodyPr>
           <a:lstStyle/>
           <a:p>
-            <a:pPr algn="ctr">
-              <a:defRPr sz="2800" b="0">
-                <a:solidFill>
-                  <a:srgbClr val="202020"/>
-                </a:solidFill>
-                <a:latin typeface="Calibri"/>
-              </a:defRPr>
-            </a:pPr>
-            <a:r>
-              <a:t>One command. Full AI coding environment.</a:t>
-            </a:r>
-          </a:p>
-        </p:txBody>
-      </p:sp>
-      <p:sp>
-        <p:nvSpPr>
-          <p:cNvPr id="5" name="TextBox 4"/>
-          <p:cNvSpPr txBox="1"/>
-          <p:nvPr/>
-        </p:nvSpPr>
-        <p:spPr>
-          <a:xfrm>
-            <a:off x="1371600" y="4114800"/>
-            <a:ext cx="9144000" cy="457200"/>
-          </a:xfrm>
-          <a:prstGeom prst="rect">
-            <a:avLst/>
-          </a:prstGeom>
-          <a:noFill/>
-        </p:spPr>
-        <p:txBody>
-          <a:bodyPr wrap="square">
-            <a:spAutoFit/>
-          </a:bodyPr>
-          <a:lstStyle/>
-          <a:p>
-            <a:pPr algn="ctr">
-              <a:defRPr sz="2400" b="0">
-                <a:solidFill>
-                  <a:srgbClr val="5F6368"/>
-                </a:solidFill>
-                <a:latin typeface="Consolas"/>
-              </a:defRPr>
-            </a:pPr>
-            <a:r>
-              <a:t>npx f2g-telco init</a:t>
-            </a:r>
-          </a:p>
-        </p:txBody>
-      </p:sp>
-      <p:sp>
-        <p:nvSpPr>
-          <p:cNvPr id="6" name="TextBox 5"/>
-          <p:cNvSpPr txBox="1"/>
-          <p:nvPr/>
-        </p:nvSpPr>
-        <p:spPr>
-          <a:xfrm>
-            <a:off x="1371600" y="5029200"/>
-            <a:ext cx="9144000" cy="457200"/>
-          </a:xfrm>
-          <a:prstGeom prst="rect">
-            <a:avLst/>
-          </a:prstGeom>
-          <a:noFill/>
-        </p:spPr>
-        <p:txBody>
-          <a:bodyPr wrap="square">
-            <a:spAutoFit/>
-          </a:bodyPr>
-          <a:lstStyle/>
-          <a:p>
-            <a:pPr algn="ctr">
-              <a:defRPr sz="1800" b="0">
-                <a:solidFill>
-                  <a:srgbClr val="4285F4"/>
-                </a:solidFill>
-                <a:latin typeface="Calibri"/>
-              </a:defRPr>
-            </a:pPr>
-            <a:r>
-              <a:t>github.com/suzannekouemou/f2g-telco</a:t>
-            </a:r>
-          </a:p>
-        </p:txBody>
-      </p:sp>
-      <p:sp>
-        <p:nvSpPr>
-          <p:cNvPr id="7" name="TextBox 6"/>
-          <p:cNvSpPr txBox="1"/>
-          <p:nvPr/>
-        </p:nvSpPr>
-        <p:spPr>
-          <a:xfrm>
-            <a:off x="1371600" y="5669280"/>
-            <a:ext cx="9144000" cy="457200"/>
-          </a:xfrm>
-          <a:prstGeom prst="rect">
-            <a:avLst/>
-          </a:prstGeom>
-          <a:noFill/>
-        </p:spPr>
-        <p:txBody>
-          <a:bodyPr wrap="square">
-            <a:spAutoFit/>
-          </a:bodyPr>
-          <a:lstStyle/>
-          <a:p>
-            <a:pPr algn="ctr">
-              <a:defRPr sz="1600" b="0">
-                <a:solidFill>
-                  <a:srgbClr val="5F6368"/>
-                </a:solidFill>
-                <a:latin typeface="Calibri"/>
-              </a:defRPr>
-            </a:pPr>
-            <a:r>
-              <a:t>MIT Licensed  •  Open Source  •  Free</a:t>
+            <a:pPr>
+              <a:spcAft>
+                <a:spcPts val="800"/>
+              </a:spcAft>
+              <a:defRPr sz="1700">
+                <a:solidFill>
+                  <a:srgbClr val="202020"/>
+                </a:solidFill>
+                <a:latin typeface="Calibri"/>
+              </a:defRPr>
+            </a:pPr>
+            <a:r>
+              <a:t>Language: TypeScript (compiled to ESM)</a:t>
+            </a:r>
+          </a:p>
+          <a:p>
+            <a:pPr>
+              <a:spcAft>
+                <a:spcPts val="800"/>
+              </a:spcAft>
+              <a:defRPr sz="1700">
+                <a:solidFill>
+                  <a:srgbClr val="202020"/>
+                </a:solidFill>
+                <a:latin typeface="Calibri"/>
+              </a:defRPr>
+            </a:pPr>
+            <a:r>
+              <a:t>License: MIT</a:t>
+            </a:r>
+          </a:p>
+          <a:p>
+            <a:pPr>
+              <a:spcAft>
+                <a:spcPts val="800"/>
+              </a:spcAft>
+              <a:defRPr sz="1700">
+                <a:solidFill>
+                  <a:srgbClr val="202020"/>
+                </a:solidFill>
+                <a:latin typeface="Calibri"/>
+              </a:defRPr>
+            </a:pPr>
+            <a:r>
+              <a:t>Node: 18+ required</a:t>
+            </a:r>
+          </a:p>
+          <a:p>
+            <a:pPr>
+              <a:spcAft>
+                <a:spcPts val="800"/>
+              </a:spcAft>
+              <a:defRPr sz="1700">
+                <a:solidFill>
+                  <a:srgbClr val="202020"/>
+                </a:solidFill>
+                <a:latin typeface="Calibri"/>
+              </a:defRPr>
+            </a:pPr>
+            <a:r>
+              <a:t>Distribution: npm (npx f2g-telco init — zero global install)</a:t>
+            </a:r>
+          </a:p>
+          <a:p>
+            <a:pPr>
+              <a:spcAft>
+                <a:spcPts val="800"/>
+              </a:spcAft>
+              <a:defRPr sz="1700">
+                <a:solidFill>
+                  <a:srgbClr val="202020"/>
+                </a:solidFill>
+                <a:latin typeface="Calibri"/>
+              </a:defRPr>
+            </a:pPr>
+            <a:r>
+              <a:t>CI: GitHub Actions on Node 18, 20, 22</a:t>
+            </a:r>
+          </a:p>
+          <a:p>
+            <a:pPr>
+              <a:spcAft>
+                <a:spcPts val="800"/>
+              </a:spcAft>
+              <a:defRPr sz="1700">
+                <a:solidFill>
+                  <a:srgbClr val="202020"/>
+                </a:solidFill>
+                <a:latin typeface="Calibri"/>
+              </a:defRPr>
+            </a:pPr>
+            <a:r>
+              <a:t>Tests: 13 test cases covering registry, config generation, CLI commands</a:t>
+            </a:r>
+          </a:p>
+          <a:p>
+            <a:pPr>
+              <a:spcAft>
+                <a:spcPts val="800"/>
+              </a:spcAft>
+              <a:defRPr sz="1700">
+                <a:solidFill>
+                  <a:srgbClr val="202020"/>
+                </a:solidFill>
+                <a:latin typeface="Calibri"/>
+              </a:defRPr>
+            </a:pPr>
+            <a:r>
+              <a:t>Registry: JSON files (mcps.json, providers.json, skills.json) — easy to extend</a:t>
+            </a:r>
+          </a:p>
+          <a:p>
+            <a:pPr>
+              <a:spcAft>
+                <a:spcPts val="800"/>
+              </a:spcAft>
+              <a:defRPr sz="1700">
+                <a:solidFill>
+                  <a:srgbClr val="202020"/>
+                </a:solidFill>
+                <a:latin typeface="Calibri"/>
+              </a:defRPr>
+            </a:pPr>
+            <a:r>
+              <a:t>Logging: All commands log to ~/.f2g-telco/f2g-telco.log</a:t>
+            </a:r>
+          </a:p>
+          <a:p>
+            <a:pPr>
+              <a:spcAft>
+                <a:spcPts val="800"/>
+              </a:spcAft>
+              <a:defRPr sz="1700">
+                <a:solidFill>
+                  <a:srgbClr val="202020"/>
+                </a:solidFill>
+                <a:latin typeface="Calibri"/>
+              </a:defRPr>
+            </a:pPr>
+            <a:r>
+              <a:t>Error handling: Ctrl+C safe, --verbose flag for debugging</a:t>
+            </a:r>
+          </a:p>
+          <a:p>
+            <a:pPr>
+              <a:spcAft>
+                <a:spcPts val="800"/>
+              </a:spcAft>
+              <a:defRPr sz="1700">
+                <a:solidFill>
+                  <a:srgbClr val="202020"/>
+                </a:solidFill>
+                <a:latin typeface="Calibri"/>
+              </a:defRPr>
+            </a:pPr>
+            <a:r>
+              <a:t>Repo: github.com/suzannekouemou/f2g-telco</a:t>
             </a:r>
           </a:p>
         </p:txBody>
@@ -6195,7 +6439,7 @@
 </file>
 
 <file path=ppt/slides/slide18.xml><?xml version="1.0" encoding="utf-8"?>
-<p:sld xmlns:a="http://schemas.openxmlformats.org/drawingml/2006/main" xmlns:p="http://schemas.openxmlformats.org/presentationml/2006/main" xmlns:r="http://schemas.openxmlformats.org/officeDocument/2006/relationships">
+<p:sld xmlns:a="http://schemas.openxmlformats.org/drawingml/2006/main" xmlns:r="http://schemas.openxmlformats.org/officeDocument/2006/relationships" xmlns:p="http://schemas.openxmlformats.org/presentationml/2006/main">
   <p:cSld>
     <p:bg>
       <p:bgPr>
@@ -6211,7 +6455,14 @@
         <p:cNvGrpSpPr/>
         <p:nvPr/>
       </p:nvGrpSpPr>
-      <p:grpSpPr/>
+      <p:grpSpPr>
+        <a:xfrm>
+          <a:off x="0" y="0"/>
+          <a:ext cx="0" cy="0"/>
+          <a:chOff x="0" y="0"/>
+          <a:chExt cx="0" cy="0"/>
+        </a:xfrm>
+      </p:grpSpPr>
       <p:sp>
         <p:nvSpPr>
           <p:cNvPr id="2" name="TextBox 1"/>
@@ -6243,7 +6494,7 @@
               </a:defRPr>
             </a:pPr>
             <a:r>
-              <a:t>Why This Matters for the F2G-Telco Team</a:t>
+              <a:t>Live Demo Flow</a:t>
             </a:r>
           </a:p>
         </p:txBody>
@@ -6256,8 +6507,8 @@
         </p:nvSpPr>
         <p:spPr>
           <a:xfrm>
-            <a:off x="731520" y="1097280"/>
-            <a:ext cx="5486400" cy="457200"/>
+            <a:off x="1371600" y="1097280"/>
+            <a:ext cx="9144000" cy="5303520"/>
           </a:xfrm>
           <a:prstGeom prst="rect">
             <a:avLst/>
@@ -6270,179 +6521,307 @@
           </a:bodyPr>
           <a:lstStyle/>
           <a:p>
-            <a:pPr algn="l">
-              <a:defRPr sz="1900" b="1">
-                <a:solidFill>
-                  <a:srgbClr val="202020"/>
-                </a:solidFill>
-                <a:latin typeface="Calibri"/>
-              </a:defRPr>
-            </a:pPr>
-            <a:r>
-              <a:t>One shared AI brain across every team member:</a:t>
-            </a:r>
-          </a:p>
-        </p:txBody>
-      </p:sp>
-      <p:sp>
-        <p:nvSpPr>
-          <p:cNvPr id="4" name="TextBox 3"/>
-          <p:cNvSpPr txBox="1"/>
-          <p:nvPr/>
-        </p:nvSpPr>
-        <p:spPr>
-          <a:xfrm>
-            <a:off x="731520" y="1737360"/>
-            <a:ext cx="5486400" cy="4572000"/>
-          </a:xfrm>
-          <a:prstGeom prst="rect">
-            <a:avLst/>
-          </a:prstGeom>
-          <a:noFill/>
-        </p:spPr>
-        <p:txBody>
-          <a:bodyPr wrap="square">
-            <a:spAutoFit/>
-          </a:bodyPr>
-          <a:lstStyle/>
-          <a:p>
-            <a:pPr>
-              <a:spcAft>
-                <a:spcPts val="800"/>
-              </a:spcAft>
-              <a:defRPr sz="1600">
-                <a:solidFill>
-                  <a:srgbClr val="202020"/>
-                </a:solidFill>
-                <a:latin typeface="Calibri"/>
-              </a:defRPr>
-            </a:pPr>
-            <a:r>
-              <a:t>🧠  Global context — what one developer learns, every AI instance knows</a:t>
-            </a:r>
-          </a:p>
-          <a:p>
-            <a:pPr>
-              <a:spcAft>
-                <a:spcPts val="800"/>
-              </a:spcAft>
-              <a:defRPr sz="1600">
-                <a:solidFill>
-                  <a:srgbClr val="202020"/>
-                </a:solidFill>
-                <a:latin typeface="Calibri"/>
-              </a:defRPr>
-            </a:pPr>
-            <a:r>
-              <a:t>🔄  No repeated explanations — onboard a new member, the AI already has the history</a:t>
-            </a:r>
-          </a:p>
-          <a:p>
-            <a:pPr>
-              <a:spcAft>
-                <a:spcPts val="800"/>
-              </a:spcAft>
-              <a:defRPr sz="1600">
-                <a:solidFill>
-                  <a:srgbClr val="202020"/>
-                </a:solidFill>
-                <a:latin typeface="Calibri"/>
-              </a:defRPr>
-            </a:pPr>
-            <a:r>
-              <a:t>🤝  Seamless handoffs — Dev A starts a task, Dev B picks it up with full context</a:t>
-            </a:r>
-          </a:p>
-          <a:p>
-            <a:pPr>
-              <a:spcAft>
-                <a:spcPts val="800"/>
-              </a:spcAft>
-              <a:defRPr sz="1600">
-                <a:solidFill>
-                  <a:srgbClr val="202020"/>
-                </a:solidFill>
-                <a:latin typeface="Calibri"/>
-              </a:defRPr>
-            </a:pPr>
-            <a:r>
-              <a:t>📈  Compound knowledge — every fix, every decision, every insight accumulates</a:t>
-            </a:r>
-          </a:p>
-          <a:p>
-            <a:pPr>
-              <a:spcAft>
-                <a:spcPts val="800"/>
-              </a:spcAft>
-              <a:defRPr sz="1600">
-                <a:solidFill>
-                  <a:srgbClr val="202020"/>
-                </a:solidFill>
-                <a:latin typeface="Calibri"/>
-              </a:defRPr>
-            </a:pPr>
-            <a:r>
-              <a:t>⚡  Faster debugging — AI recalls past solutions across the whole team's experience</a:t>
-            </a:r>
-          </a:p>
-          <a:p>
-            <a:pPr>
-              <a:spcAft>
-                <a:spcPts val="800"/>
-              </a:spcAft>
-              <a:defRPr sz="1600">
-                <a:solidFill>
-                  <a:srgbClr val="202020"/>
-                </a:solidFill>
-                <a:latin typeface="Calibri"/>
-              </a:defRPr>
-            </a:pPr>
-            <a:r>
-              <a:t>🏗️  Consistent architecture — AI enforces the same patterns team-wide</a:t>
-            </a:r>
-          </a:p>
-          <a:p>
-            <a:pPr>
-              <a:spcAft>
-                <a:spcPts val="800"/>
-              </a:spcAft>
-              <a:defRPr sz="1600">
-                <a:solidFill>
-                  <a:srgbClr val="202020"/>
-                </a:solidFill>
-                <a:latin typeface="Calibri"/>
-              </a:defRPr>
-            </a:pPr>
-            <a:r>
-              <a:t>🔒  Each member still owns their own API keys and local setup</a:t>
-            </a:r>
-          </a:p>
-        </p:txBody>
-      </p:sp>
-      <p:pic>
-        <p:nvPicPr>
-          <p:cNvPr id="5" name="Picture 4" descr="team-scenario.png"/>
-          <p:cNvPicPr>
-            <a:picLocks noChangeAspect="1"/>
-          </p:cNvPicPr>
-          <p:nvPr/>
-        </p:nvPicPr>
-        <p:blipFill>
-          <a:blip r:embed="rId2"/>
-          <a:stretch>
-            <a:fillRect/>
-          </a:stretch>
-        </p:blipFill>
-        <p:spPr>
-          <a:xfrm>
-            <a:off x="6400800" y="1188720"/>
-            <a:ext cx="5486400" cy="2168013"/>
-          </a:xfrm>
-          <a:prstGeom prst="rect">
-            <a:avLst/>
-          </a:prstGeom>
-        </p:spPr>
-      </p:pic>
+            <a:pPr>
+              <a:defRPr sz="1400" b="1">
+                <a:solidFill>
+                  <a:srgbClr val="1A73E8"/>
+                </a:solidFill>
+                <a:latin typeface="Consolas"/>
+              </a:defRPr>
+            </a:pPr>
+            <a:r>
+              <a:t>$ npx f2g-telco init</a:t>
+            </a:r>
+          </a:p>
+          <a:p>
+            <a:pPr>
+              <a:defRPr sz="1400">
+                <a:solidFill>
+                  <a:srgbClr val="202020"/>
+                </a:solidFill>
+                <a:latin typeface="Consolas"/>
+              </a:defRPr>
+            </a:pPr>
+            <a:endParaRPr/>
+          </a:p>
+          <a:p>
+            <a:pPr>
+              <a:defRPr sz="1400">
+                <a:solidFill>
+                  <a:srgbClr val="202020"/>
+                </a:solidFill>
+                <a:latin typeface="Consolas"/>
+              </a:defRPr>
+            </a:pPr>
+            <a:r>
+              <a:t>  Step 1/5  Detecting AI tools...</a:t>
+            </a:r>
+          </a:p>
+          <a:p>
+            <a:pPr>
+              <a:defRPr sz="1400">
+                <a:solidFill>
+                  <a:srgbClr val="0D9453"/>
+                </a:solidFill>
+                <a:latin typeface="Consolas"/>
+              </a:defRPr>
+            </a:pPr>
+            <a:r>
+              <a:t>  ✔ Crush v0.51.3 detected</a:t>
+            </a:r>
+          </a:p>
+          <a:p>
+            <a:pPr>
+              <a:defRPr sz="1400">
+                <a:solidFill>
+                  <a:srgbClr val="202020"/>
+                </a:solidFill>
+                <a:latin typeface="Consolas"/>
+              </a:defRPr>
+            </a:pPr>
+            <a:endParaRPr/>
+          </a:p>
+          <a:p>
+            <a:pPr>
+              <a:defRPr sz="1400">
+                <a:solidFill>
+                  <a:srgbClr val="202020"/>
+                </a:solidFill>
+                <a:latin typeface="Consolas"/>
+              </a:defRPr>
+            </a:pPr>
+            <a:r>
+              <a:t>  Step 2/5  Select providers:</a:t>
+            </a:r>
+          </a:p>
+          <a:p>
+            <a:pPr>
+              <a:defRPr sz="1400">
+                <a:solidFill>
+                  <a:srgbClr val="0D9453"/>
+                </a:solidFill>
+                <a:latin typeface="Consolas"/>
+              </a:defRPr>
+            </a:pPr>
+            <a:r>
+              <a:t>  ✔ GitHub Copilot (already authenticated)</a:t>
+            </a:r>
+          </a:p>
+          <a:p>
+            <a:pPr>
+              <a:defRPr sz="1400">
+                <a:solidFill>
+                  <a:srgbClr val="0D9453"/>
+                </a:solidFill>
+                <a:latin typeface="Consolas"/>
+              </a:defRPr>
+            </a:pPr>
+            <a:r>
+              <a:t>  ✔ NVIDIA NIM (key entered)</a:t>
+            </a:r>
+          </a:p>
+          <a:p>
+            <a:pPr>
+              <a:defRPr sz="1400">
+                <a:solidFill>
+                  <a:srgbClr val="5F6368"/>
+                </a:solidFill>
+                <a:latin typeface="Consolas"/>
+              </a:defRPr>
+            </a:pPr>
+            <a:r>
+              <a:t>  ⊘ Groq (skipped)</a:t>
+            </a:r>
+          </a:p>
+          <a:p>
+            <a:pPr>
+              <a:defRPr sz="1400">
+                <a:solidFill>
+                  <a:srgbClr val="202020"/>
+                </a:solidFill>
+                <a:latin typeface="Consolas"/>
+              </a:defRPr>
+            </a:pPr>
+            <a:endParaRPr/>
+          </a:p>
+          <a:p>
+            <a:pPr>
+              <a:defRPr sz="1400">
+                <a:solidFill>
+                  <a:srgbClr val="202020"/>
+                </a:solidFill>
+                <a:latin typeface="Consolas"/>
+              </a:defRPr>
+            </a:pPr>
+            <a:r>
+              <a:t>  Step 3/5  Configuring MCP servers...</a:t>
+            </a:r>
+          </a:p>
+          <a:p>
+            <a:pPr>
+              <a:defRPr sz="1400">
+                <a:solidFill>
+                  <a:srgbClr val="0D9453"/>
+                </a:solidFill>
+                <a:latin typeface="Consolas"/>
+              </a:defRPr>
+            </a:pPr>
+            <a:r>
+              <a:t>  ✔ mem0 configured (via npx)</a:t>
+            </a:r>
+          </a:p>
+          <a:p>
+            <a:pPr>
+              <a:defRPr sz="1400">
+                <a:solidFill>
+                  <a:srgbClr val="0D9453"/>
+                </a:solidFill>
+                <a:latin typeface="Consolas"/>
+              </a:defRPr>
+            </a:pPr>
+            <a:r>
+              <a:t>  ✔ context7 configured (via npx)</a:t>
+            </a:r>
+          </a:p>
+          <a:p>
+            <a:pPr>
+              <a:defRPr sz="1400">
+                <a:solidFill>
+                  <a:srgbClr val="0D9453"/>
+                </a:solidFill>
+                <a:latin typeface="Consolas"/>
+              </a:defRPr>
+            </a:pPr>
+            <a:r>
+              <a:t>  ✔ contextgraph installed</a:t>
+            </a:r>
+          </a:p>
+          <a:p>
+            <a:pPr>
+              <a:defRPr sz="1400">
+                <a:solidFill>
+                  <a:srgbClr val="202020"/>
+                </a:solidFill>
+                <a:latin typeface="Consolas"/>
+              </a:defRPr>
+            </a:pPr>
+            <a:r>
+              <a:t>  ... 10 more ...</a:t>
+            </a:r>
+          </a:p>
+          <a:p>
+            <a:pPr>
+              <a:defRPr sz="1400">
+                <a:solidFill>
+                  <a:srgbClr val="202020"/>
+                </a:solidFill>
+                <a:latin typeface="Consolas"/>
+              </a:defRPr>
+            </a:pPr>
+            <a:endParaRPr/>
+          </a:p>
+          <a:p>
+            <a:pPr>
+              <a:defRPr sz="1400">
+                <a:solidFill>
+                  <a:srgbClr val="202020"/>
+                </a:solidFill>
+                <a:latin typeface="Consolas"/>
+              </a:defRPr>
+            </a:pPr>
+            <a:r>
+              <a:t>  Step 4/5  Installing skills...</a:t>
+            </a:r>
+          </a:p>
+          <a:p>
+            <a:pPr>
+              <a:defRPr sz="1400">
+                <a:solidFill>
+                  <a:srgbClr val="0D9453"/>
+                </a:solidFill>
+                <a:latin typeface="Consolas"/>
+              </a:defRPr>
+            </a:pPr>
+            <a:r>
+              <a:t>  ✔ awesome-copilot (16 agents, 16 skills)</a:t>
+            </a:r>
+          </a:p>
+          <a:p>
+            <a:pPr>
+              <a:defRPr sz="1400">
+                <a:solidFill>
+                  <a:srgbClr val="202020"/>
+                </a:solidFill>
+                <a:latin typeface="Consolas"/>
+              </a:defRPr>
+            </a:pPr>
+            <a:endParaRPr/>
+          </a:p>
+          <a:p>
+            <a:pPr>
+              <a:defRPr sz="1400">
+                <a:solidFill>
+                  <a:srgbClr val="202020"/>
+                </a:solidFill>
+                <a:latin typeface="Consolas"/>
+              </a:defRPr>
+            </a:pPr>
+            <a:r>
+              <a:t>  Step 5/5  Writing configs...</a:t>
+            </a:r>
+          </a:p>
+          <a:p>
+            <a:pPr>
+              <a:defRPr sz="1400">
+                <a:solidFill>
+                  <a:srgbClr val="0D9453"/>
+                </a:solidFill>
+                <a:latin typeface="Consolas"/>
+              </a:defRPr>
+            </a:pPr>
+            <a:r>
+              <a:t>  ✔ crush.json written</a:t>
+            </a:r>
+          </a:p>
+          <a:p>
+            <a:pPr>
+              <a:defRPr sz="1400">
+                <a:solidFill>
+                  <a:srgbClr val="0D9453"/>
+                </a:solidFill>
+                <a:latin typeface="Consolas"/>
+              </a:defRPr>
+            </a:pPr>
+            <a:r>
+              <a:t>  ✔ INVENTORY.md generated</a:t>
+            </a:r>
+          </a:p>
+          <a:p>
+            <a:pPr>
+              <a:defRPr sz="1400">
+                <a:solidFill>
+                  <a:srgbClr val="202020"/>
+                </a:solidFill>
+                <a:latin typeface="Consolas"/>
+              </a:defRPr>
+            </a:pPr>
+            <a:endParaRPr/>
+          </a:p>
+          <a:p>
+            <a:pPr>
+              <a:defRPr sz="1400">
+                <a:solidFill>
+                  <a:srgbClr val="202020"/>
+                </a:solidFill>
+                <a:latin typeface="Consolas"/>
+              </a:defRPr>
+            </a:pPr>
+            <a:r>
+              <a:t>  🎉 Done! Restart your terminal and start coding.</a:t>
+            </a:r>
+          </a:p>
+        </p:txBody>
+      </p:sp>
     </p:spTree>
   </p:cSld>
   <p:clrMapOvr>
@@ -6452,7 +6831,7 @@
 </file>
 
 <file path=ppt/slides/slide19.xml><?xml version="1.0" encoding="utf-8"?>
-<p:sld xmlns:a="http://schemas.openxmlformats.org/drawingml/2006/main" xmlns:p="http://schemas.openxmlformats.org/presentationml/2006/main" xmlns:r="http://schemas.openxmlformats.org/officeDocument/2006/relationships">
+<p:sld xmlns:a="http://schemas.openxmlformats.org/drawingml/2006/main" xmlns:r="http://schemas.openxmlformats.org/officeDocument/2006/relationships" xmlns:p="http://schemas.openxmlformats.org/presentationml/2006/main">
   <p:cSld>
     <p:bg>
       <p:bgPr>
@@ -6468,7 +6847,14 @@
         <p:cNvGrpSpPr/>
         <p:nvPr/>
       </p:nvGrpSpPr>
-      <p:grpSpPr/>
+      <p:grpSpPr>
+        <a:xfrm>
+          <a:off x="0" y="0"/>
+          <a:ext cx="0" cy="0"/>
+          <a:chOff x="0" y="0"/>
+          <a:chExt cx="0" cy="0"/>
+        </a:xfrm>
+      </p:grpSpPr>
       <p:sp>
         <p:nvSpPr>
           <p:cNvPr id="2" name="TextBox 1"/>
@@ -6500,7 +6886,7 @@
               </a:defRPr>
             </a:pPr>
             <a:r>
-              <a:t>Real Scenario: Shared Context in Action</a:t>
+              <a:t>Roadmap &amp; Next Steps</a:t>
             </a:r>
           </a:p>
         </p:txBody>
@@ -6513,8 +6899,8 @@
         </p:nvSpPr>
         <p:spPr>
           <a:xfrm>
-            <a:off x="731520" y="1097280"/>
-            <a:ext cx="10058400" cy="4572000"/>
+            <a:off x="731520" y="1188720"/>
+            <a:ext cx="10058400" cy="3657600"/>
           </a:xfrm>
           <a:prstGeom prst="rect">
             <a:avLst/>
@@ -6531,246 +6917,187 @@
               <a:spcAft>
                 <a:spcPts val="800"/>
               </a:spcAft>
-              <a:defRPr sz="1600">
-                <a:solidFill>
-                  <a:srgbClr val="202020"/>
-                </a:solidFill>
-                <a:latin typeface="Calibri"/>
-              </a:defRPr>
-            </a:pPr>
-            <a:r>
-              <a:t>Monday morning — Developer A (using Kiro):</a:t>
-            </a:r>
-          </a:p>
-          <a:p>
-            <a:pPr>
-              <a:spcAft>
-                <a:spcPts val="800"/>
-              </a:spcAft>
-              <a:defRPr sz="1600">
-                <a:solidFill>
-                  <a:srgbClr val="202020"/>
-                </a:solidFill>
-                <a:latin typeface="Calibri"/>
-              </a:defRPr>
-            </a:pPr>
-            <a:r>
-              <a:t>     → Fixes a critical bug in the payment module</a:t>
-            </a:r>
-          </a:p>
-          <a:p>
-            <a:pPr>
-              <a:spcAft>
-                <a:spcPts val="800"/>
-              </a:spcAft>
-              <a:defRPr sz="1600">
-                <a:solidFill>
-                  <a:srgbClr val="202020"/>
-                </a:solidFill>
-                <a:latin typeface="Calibri"/>
-              </a:defRPr>
-            </a:pPr>
-            <a:r>
-              <a:t>     → AI stores: "Root cause was race condition in transaction queue"</a:t>
-            </a:r>
-          </a:p>
-          <a:p>
-            <a:pPr>
-              <a:spcAft>
-                <a:spcPts val="800"/>
-              </a:spcAft>
-              <a:defRPr sz="1600">
-                <a:solidFill>
-                  <a:srgbClr val="202020"/>
-                </a:solidFill>
-                <a:latin typeface="Calibri"/>
-              </a:defRPr>
-            </a:pPr>
-          </a:p>
-          <a:p>
-            <a:pPr>
-              <a:spcAft>
-                <a:spcPts val="800"/>
-              </a:spcAft>
-              <a:defRPr sz="1600">
-                <a:solidFill>
-                  <a:srgbClr val="202020"/>
-                </a:solidFill>
-                <a:latin typeface="Calibri"/>
-              </a:defRPr>
-            </a:pPr>
-            <a:r>
-              <a:t>Monday afternoon — Developer B (using Crush):</a:t>
-            </a:r>
-          </a:p>
-          <a:p>
-            <a:pPr>
-              <a:spcAft>
-                <a:spcPts val="800"/>
-              </a:spcAft>
-              <a:defRPr sz="1600">
-                <a:solidFill>
-                  <a:srgbClr val="202020"/>
-                </a:solidFill>
-                <a:latin typeface="Calibri"/>
-              </a:defRPr>
-            </a:pPr>
-            <a:r>
-              <a:t>     → Starts working on the same module</a:t>
-            </a:r>
-          </a:p>
-          <a:p>
-            <a:pPr>
-              <a:spcAft>
-                <a:spcPts val="800"/>
-              </a:spcAft>
-              <a:defRPr sz="1600">
-                <a:solidFill>
-                  <a:srgbClr val="202020"/>
-                </a:solidFill>
-                <a:latin typeface="Calibri"/>
-              </a:defRPr>
-            </a:pPr>
-            <a:r>
-              <a:t>     → AI recalls A's fix automatically — no Slack message needed</a:t>
-            </a:r>
-          </a:p>
-          <a:p>
-            <a:pPr>
-              <a:spcAft>
-                <a:spcPts val="800"/>
-              </a:spcAft>
-              <a:defRPr sz="1600">
-                <a:solidFill>
-                  <a:srgbClr val="202020"/>
-                </a:solidFill>
-                <a:latin typeface="Calibri"/>
-              </a:defRPr>
-            </a:pPr>
-            <a:r>
-              <a:t>     → Builds on top of it instead of duplicating effort</a:t>
-            </a:r>
-          </a:p>
-          <a:p>
-            <a:pPr>
-              <a:spcAft>
-                <a:spcPts val="800"/>
-              </a:spcAft>
-              <a:defRPr sz="1600">
-                <a:solidFill>
-                  <a:srgbClr val="202020"/>
-                </a:solidFill>
-                <a:latin typeface="Calibri"/>
-              </a:defRPr>
-            </a:pPr>
-          </a:p>
-          <a:p>
-            <a:pPr>
-              <a:spcAft>
-                <a:spcPts val="800"/>
-              </a:spcAft>
-              <a:defRPr sz="1600">
-                <a:solidFill>
-                  <a:srgbClr val="202020"/>
-                </a:solidFill>
-                <a:latin typeface="Calibri"/>
-              </a:defRPr>
-            </a:pPr>
-            <a:r>
-              <a:t>Tuesday — Developer C (new team member):</a:t>
-            </a:r>
-          </a:p>
-          <a:p>
-            <a:pPr>
-              <a:spcAft>
-                <a:spcPts val="800"/>
-              </a:spcAft>
-              <a:defRPr sz="1600">
-                <a:solidFill>
-                  <a:srgbClr val="202020"/>
-                </a:solidFill>
-                <a:latin typeface="Calibri"/>
-              </a:defRPr>
-            </a:pPr>
-            <a:r>
-              <a:t>     → Runs npx f2g-telco init — full environment in 5 minutes</a:t>
-            </a:r>
-          </a:p>
-          <a:p>
-            <a:pPr>
-              <a:spcAft>
-                <a:spcPts val="800"/>
-              </a:spcAft>
-              <a:defRPr sz="1600">
-                <a:solidFill>
-                  <a:srgbClr val="202020"/>
-                </a:solidFill>
-                <a:latin typeface="Calibri"/>
-              </a:defRPr>
-            </a:pPr>
-            <a:r>
-              <a:t>     → AI already knows the entire team's history</a:t>
-            </a:r>
-          </a:p>
-          <a:p>
-            <a:pPr>
-              <a:spcAft>
-                <a:spcPts val="800"/>
-              </a:spcAft>
-              <a:defRPr sz="1600">
-                <a:solidFill>
-                  <a:srgbClr val="202020"/>
-                </a:solidFill>
-                <a:latin typeface="Calibri"/>
-              </a:defRPr>
-            </a:pPr>
-            <a:r>
-              <a:t>     → Productive from day one, not week two</a:t>
-            </a:r>
-          </a:p>
-          <a:p>
-            <a:pPr>
-              <a:spcAft>
-                <a:spcPts val="800"/>
-              </a:spcAft>
-              <a:defRPr sz="1600">
-                <a:solidFill>
-                  <a:srgbClr val="202020"/>
-                </a:solidFill>
-                <a:latin typeface="Calibri"/>
-              </a:defRPr>
-            </a:pPr>
-          </a:p>
-          <a:p>
-            <a:pPr>
-              <a:spcAft>
-                <a:spcPts val="800"/>
-              </a:spcAft>
-              <a:defRPr sz="1600" b="1">
-                <a:solidFill>
-                  <a:srgbClr val="0D9453"/>
-                </a:solidFill>
-                <a:latin typeface="Calibri"/>
-              </a:defRPr>
-            </a:pPr>
-            <a:r>
-              <a:t>The AI becomes the team's institutional memory.</a:t>
-            </a:r>
-          </a:p>
-          <a:p>
-            <a:pPr>
-              <a:spcAft>
-                <a:spcPts val="800"/>
-              </a:spcAft>
-              <a:defRPr sz="1600" b="1">
-                <a:solidFill>
-                  <a:srgbClr val="0D9453"/>
-                </a:solidFill>
-                <a:latin typeface="Calibri"/>
-              </a:defRPr>
-            </a:pPr>
-            <a:r>
-              <a:t>No one has to write handoff docs. No context is ever lost.</a:t>
+              <a:defRPr sz="1700">
+                <a:solidFill>
+                  <a:srgbClr val="202020"/>
+                </a:solidFill>
+                <a:latin typeface="Calibri"/>
+              </a:defRPr>
+            </a:pPr>
+            <a:r>
+              <a:t>✅  v0.1.3 — Published on npm, 13 MCPs, 7 providers, 3 skill sources</a:t>
+            </a:r>
+          </a:p>
+          <a:p>
+            <a:pPr>
+              <a:spcAft>
+                <a:spcPts val="800"/>
+              </a:spcAft>
+              <a:defRPr sz="1700">
+                <a:solidFill>
+                  <a:srgbClr val="202020"/>
+                </a:solidFill>
+                <a:latin typeface="Calibri"/>
+              </a:defRPr>
+            </a:pPr>
+            <a:endParaRPr/>
+          </a:p>
+          <a:p>
+            <a:pPr>
+              <a:spcAft>
+                <a:spcPts val="800"/>
+              </a:spcAft>
+              <a:defRPr sz="1700">
+                <a:solidFill>
+                  <a:srgbClr val="202020"/>
+                </a:solidFill>
+                <a:latin typeface="Calibri"/>
+              </a:defRPr>
+            </a:pPr>
+            <a:r>
+              <a:t>🔜  v0.2.0 — Planned</a:t>
+            </a:r>
+          </a:p>
+          <a:p>
+            <a:pPr>
+              <a:spcAft>
+                <a:spcPts val="800"/>
+              </a:spcAft>
+              <a:defRPr sz="1700">
+                <a:solidFill>
+                  <a:srgbClr val="202020"/>
+                </a:solidFill>
+                <a:latin typeface="Calibri"/>
+              </a:defRPr>
+            </a:pPr>
+            <a:r>
+              <a:t>     • f2g-telco update — pull latest registries, refresh configs</a:t>
+            </a:r>
+          </a:p>
+          <a:p>
+            <a:pPr>
+              <a:spcAft>
+                <a:spcPts val="800"/>
+              </a:spcAft>
+              <a:defRPr sz="1700">
+                <a:solidFill>
+                  <a:srgbClr val="202020"/>
+                </a:solidFill>
+                <a:latin typeface="Calibri"/>
+              </a:defRPr>
+            </a:pPr>
+            <a:r>
+              <a:t>     • f2g-telco doctor — deeper health checks (MCP connectivity, model availability)</a:t>
+            </a:r>
+          </a:p>
+          <a:p>
+            <a:pPr>
+              <a:spcAft>
+                <a:spcPts val="800"/>
+              </a:spcAft>
+              <a:defRPr sz="1700">
+                <a:solidFill>
+                  <a:srgbClr val="202020"/>
+                </a:solidFill>
+                <a:latin typeface="Calibri"/>
+              </a:defRPr>
+            </a:pPr>
+            <a:r>
+              <a:t>     • More skill sources from the community</a:t>
+            </a:r>
+          </a:p>
+          <a:p>
+            <a:pPr>
+              <a:spcAft>
+                <a:spcPts val="800"/>
+              </a:spcAft>
+              <a:defRPr sz="1700">
+                <a:solidFill>
+                  <a:srgbClr val="202020"/>
+                </a:solidFill>
+                <a:latin typeface="Calibri"/>
+              </a:defRPr>
+            </a:pPr>
+            <a:endParaRPr/>
+          </a:p>
+          <a:p>
+            <a:pPr>
+              <a:spcAft>
+                <a:spcPts val="800"/>
+              </a:spcAft>
+              <a:defRPr sz="1700">
+                <a:solidFill>
+                  <a:srgbClr val="202020"/>
+                </a:solidFill>
+                <a:latin typeface="Calibri"/>
+              </a:defRPr>
+            </a:pPr>
+            <a:r>
+              <a:t>🔮  Future</a:t>
+            </a:r>
+          </a:p>
+          <a:p>
+            <a:pPr>
+              <a:spcAft>
+                <a:spcPts val="800"/>
+              </a:spcAft>
+              <a:defRPr sz="1700">
+                <a:solidFill>
+                  <a:srgbClr val="202020"/>
+                </a:solidFill>
+                <a:latin typeface="Calibri"/>
+              </a:defRPr>
+            </a:pPr>
+            <a:r>
+              <a:t>     • Team profiles — share configs across an organization</a:t>
+            </a:r>
+          </a:p>
+          <a:p>
+            <a:pPr>
+              <a:spcAft>
+                <a:spcPts val="800"/>
+              </a:spcAft>
+              <a:defRPr sz="1700">
+                <a:solidFill>
+                  <a:srgbClr val="202020"/>
+                </a:solidFill>
+                <a:latin typeface="Calibri"/>
+              </a:defRPr>
+            </a:pPr>
+            <a:r>
+              <a:t>     • Plugin system — third-party MCP registries</a:t>
+            </a:r>
+          </a:p>
+          <a:p>
+            <a:pPr>
+              <a:spcAft>
+                <a:spcPts val="800"/>
+              </a:spcAft>
+              <a:defRPr sz="1700">
+                <a:solidFill>
+                  <a:srgbClr val="202020"/>
+                </a:solidFill>
+                <a:latin typeface="Calibri"/>
+              </a:defRPr>
+            </a:pPr>
+            <a:r>
+              <a:t>     • VS Code / Cursor extension integration</a:t>
+            </a:r>
+          </a:p>
+          <a:p>
+            <a:pPr>
+              <a:spcAft>
+                <a:spcPts val="800"/>
+              </a:spcAft>
+              <a:defRPr sz="1700">
+                <a:solidFill>
+                  <a:srgbClr val="202020"/>
+                </a:solidFill>
+                <a:latin typeface="Calibri"/>
+              </a:defRPr>
+            </a:pPr>
+            <a:r>
+              <a:t>     • Telemetry-free usage analytics (opt-in)</a:t>
             </a:r>
           </a:p>
         </p:txBody>
@@ -7072,7 +7399,7 @@
 </file>
 
 <file path=ppt/slides/slide20.xml><?xml version="1.0" encoding="utf-8"?>
-<p:sld xmlns:a="http://schemas.openxmlformats.org/drawingml/2006/main" xmlns:p="http://schemas.openxmlformats.org/presentationml/2006/main" xmlns:r="http://schemas.openxmlformats.org/officeDocument/2006/relationships">
+<p:sld xmlns:a="http://schemas.openxmlformats.org/drawingml/2006/main" xmlns:r="http://schemas.openxmlformats.org/officeDocument/2006/relationships" xmlns:p="http://schemas.openxmlformats.org/presentationml/2006/main">
   <p:cSld>
     <p:bg>
       <p:bgPr>
@@ -7088,64 +7415,33 @@
         <p:cNvGrpSpPr/>
         <p:nvPr/>
       </p:nvGrpSpPr>
-      <p:grpSpPr/>
-      <p:sp>
-        <p:nvSpPr>
-          <p:cNvPr id="2" name="TextBox 1"/>
-          <p:cNvSpPr txBox="1"/>
+      <p:grpSpPr>
+        <a:xfrm>
+          <a:off x="0" y="0"/>
+          <a:ext cx="0" cy="0"/>
+          <a:chOff x="0" y="0"/>
+          <a:chExt cx="0" cy="0"/>
+        </a:xfrm>
+      </p:grpSpPr>
+      <p:sp>
+        <p:nvSpPr>
+          <p:cNvPr id="2" name="Rectangle 1"/>
+          <p:cNvSpPr/>
           <p:nvPr/>
         </p:nvSpPr>
         <p:spPr>
           <a:xfrm>
-            <a:off x="731520" y="365760"/>
-            <a:ext cx="10058400" cy="640080"/>
+            <a:off x="0" y="6720840"/>
+            <a:ext cx="12191695" cy="137160"/>
           </a:xfrm>
           <a:prstGeom prst="rect">
             <a:avLst/>
           </a:prstGeom>
-          <a:noFill/>
-        </p:spPr>
-        <p:txBody>
-          <a:bodyPr wrap="square">
-            <a:spAutoFit/>
-          </a:bodyPr>
-          <a:lstStyle/>
-          <a:p>
-            <a:pPr algn="l">
-              <a:defRPr sz="3200" b="1">
-                <a:solidFill>
-                  <a:srgbClr val="1A73E8"/>
-                </a:solidFill>
-                <a:latin typeface="Calibri"/>
-              </a:defRPr>
-            </a:pPr>
-            <a:r>
-              <a:t>How We Enable Shared Context</a:t>
-            </a:r>
-          </a:p>
-        </p:txBody>
-      </p:sp>
-      <p:sp>
-        <p:nvSpPr>
-          <p:cNvPr id="3" name="Rounded Rectangle 2"/>
-          <p:cNvSpPr/>
-          <p:nvPr/>
-        </p:nvSpPr>
-        <p:spPr>
-          <a:xfrm>
-            <a:off x="731520" y="1188720"/>
-            <a:ext cx="5029200" cy="4572000"/>
-          </a:xfrm>
-          <a:prstGeom prst="roundRect">
-            <a:avLst/>
-          </a:prstGeom>
           <a:solidFill>
-            <a:srgbClr val="F8F9FA"/>
+            <a:srgbClr val="1A73E8"/>
           </a:solidFill>
-          <a:ln w="25400">
-            <a:solidFill>
-              <a:srgbClr val="1A73E8"/>
-            </a:solidFill>
+          <a:ln>
+            <a:noFill/>
           </a:ln>
         </p:spPr>
         <p:style>
@@ -7167,19 +7463,20 @@
           <a:lstStyle/>
           <a:p>
             <a:pPr algn="ctr"/>
-          </a:p>
-        </p:txBody>
-      </p:sp>
-      <p:sp>
-        <p:nvSpPr>
-          <p:cNvPr id="4" name="TextBox 3"/>
+            <a:endParaRPr/>
+          </a:p>
+        </p:txBody>
+      </p:sp>
+      <p:sp>
+        <p:nvSpPr>
+          <p:cNvPr id="3" name="TextBox 2"/>
           <p:cNvSpPr txBox="1"/>
           <p:nvPr/>
         </p:nvSpPr>
         <p:spPr>
           <a:xfrm>
-            <a:off x="1097280" y="1371600"/>
-            <a:ext cx="4389120" cy="457200"/>
+            <a:off x="1371600" y="2011680"/>
+            <a:ext cx="9144000" cy="914400"/>
           </a:xfrm>
           <a:prstGeom prst="rect">
             <a:avLst/>
@@ -7192,30 +7489,30 @@
           </a:bodyPr>
           <a:lstStyle/>
           <a:p>
-            <a:pPr algn="l">
-              <a:defRPr sz="2000" b="1">
-                <a:solidFill>
-                  <a:srgbClr val="0D9453"/>
-                </a:solidFill>
-                <a:latin typeface="Calibri"/>
-              </a:defRPr>
-            </a:pPr>
-            <a:r>
-              <a:t>✅ Already Possible Today</a:t>
-            </a:r>
-          </a:p>
-        </p:txBody>
-      </p:sp>
-      <p:sp>
-        <p:nvSpPr>
-          <p:cNvPr id="5" name="TextBox 4"/>
+            <a:pPr algn="ctr">
+              <a:defRPr sz="4800" b="1">
+                <a:solidFill>
+                  <a:srgbClr val="1A73E8"/>
+                </a:solidFill>
+                <a:latin typeface="Calibri"/>
+              </a:defRPr>
+            </a:pPr>
+            <a:r>
+              <a:t>F2G-Telco</a:t>
+            </a:r>
+          </a:p>
+        </p:txBody>
+      </p:sp>
+      <p:sp>
+        <p:nvSpPr>
+          <p:cNvPr id="4" name="TextBox 3"/>
           <p:cNvSpPr txBox="1"/>
           <p:nvPr/>
         </p:nvSpPr>
         <p:spPr>
           <a:xfrm>
-            <a:off x="1097280" y="2103120"/>
-            <a:ext cx="4389120" cy="4572000"/>
+            <a:off x="1371600" y="3108960"/>
+            <a:ext cx="9144000" cy="640080"/>
           </a:xfrm>
           <a:prstGeom prst="rect">
             <a:avLst/>
@@ -7228,187 +7525,30 @@
           </a:bodyPr>
           <a:lstStyle/>
           <a:p>
-            <a:pPr>
-              <a:spcAft>
-                <a:spcPts val="800"/>
-              </a:spcAft>
-              <a:defRPr sz="1500">
-                <a:solidFill>
-                  <a:srgbClr val="202020"/>
-                </a:solidFill>
-                <a:latin typeface="Calibri"/>
-              </a:defRPr>
-            </a:pPr>
-            <a:r>
-              <a:t>• Create a shared mem0 API key</a:t>
-            </a:r>
-          </a:p>
-          <a:p>
-            <a:pPr>
-              <a:spcAft>
-                <a:spcPts val="800"/>
-              </a:spcAft>
-              <a:defRPr sz="1500">
-                <a:solidFill>
-                  <a:srgbClr val="202020"/>
-                </a:solidFill>
-                <a:latin typeface="Calibri"/>
-              </a:defRPr>
-            </a:pPr>
-            <a:r>
-              <a:t>• F2G-Telco configures it for all members</a:t>
-            </a:r>
-          </a:p>
-          <a:p>
-            <a:pPr>
-              <a:spcAft>
-                <a:spcPts val="800"/>
-              </a:spcAft>
-              <a:defRPr sz="1500">
-                <a:solidFill>
-                  <a:srgbClr val="202020"/>
-                </a:solidFill>
-                <a:latin typeface="Calibri"/>
-              </a:defRPr>
-            </a:pPr>
-            <a:r>
-              <a:t>• All AI instances read/write to same memory</a:t>
-            </a:r>
-          </a:p>
-          <a:p>
-            <a:pPr>
-              <a:spcAft>
-                <a:spcPts val="800"/>
-              </a:spcAft>
-              <a:defRPr sz="1500">
-                <a:solidFill>
-                  <a:srgbClr val="202020"/>
-                </a:solidFill>
-                <a:latin typeface="Calibri"/>
-              </a:defRPr>
-            </a:pPr>
-            <a:r>
-              <a:t>• ContextGraph hydrates from shared mem0</a:t>
-            </a:r>
-          </a:p>
-          <a:p>
-            <a:pPr>
-              <a:spcAft>
-                <a:spcPts val="800"/>
-              </a:spcAft>
-              <a:defRPr sz="1500">
-                <a:solidFill>
-                  <a:srgbClr val="202020"/>
-                </a:solidFill>
-                <a:latin typeface="Calibri"/>
-              </a:defRPr>
-            </a:pPr>
-            <a:r>
-              <a:t>• Works across Kiro AND Crush</a:t>
-            </a:r>
-          </a:p>
-          <a:p>
-            <a:pPr>
-              <a:spcAft>
-                <a:spcPts val="800"/>
-              </a:spcAft>
-              <a:defRPr sz="1500">
-                <a:solidFill>
-                  <a:srgbClr val="202020"/>
-                </a:solidFill>
-                <a:latin typeface="Calibri"/>
-              </a:defRPr>
-            </a:pPr>
-          </a:p>
-          <a:p>
-            <a:pPr>
-              <a:spcAft>
-                <a:spcPts val="800"/>
-              </a:spcAft>
-              <a:defRPr sz="1500">
-                <a:solidFill>
-                  <a:srgbClr val="202020"/>
-                </a:solidFill>
-                <a:latin typeface="Calibri"/>
-              </a:defRPr>
-            </a:pPr>
-            <a:r>
-              <a:t>Zero code changes needed.</a:t>
-            </a:r>
-          </a:p>
-          <a:p>
-            <a:pPr>
-              <a:spcAft>
-                <a:spcPts val="800"/>
-              </a:spcAft>
-              <a:defRPr sz="1500">
-                <a:solidFill>
-                  <a:srgbClr val="202020"/>
-                </a:solidFill>
-                <a:latin typeface="Calibri"/>
-              </a:defRPr>
-            </a:pPr>
-            <a:r>
-              <a:t>Just one shared key in the config.</a:t>
-            </a:r>
-          </a:p>
-        </p:txBody>
-      </p:sp>
-      <p:sp>
-        <p:nvSpPr>
-          <p:cNvPr id="6" name="Rounded Rectangle 5"/>
-          <p:cNvSpPr/>
+            <a:pPr algn="ctr">
+              <a:defRPr sz="2800" b="0">
+                <a:solidFill>
+                  <a:srgbClr val="202020"/>
+                </a:solidFill>
+                <a:latin typeface="Calibri"/>
+              </a:defRPr>
+            </a:pPr>
+            <a:r>
+              <a:t>One command. Full AI coding environment.</a:t>
+            </a:r>
+          </a:p>
+        </p:txBody>
+      </p:sp>
+      <p:sp>
+        <p:nvSpPr>
+          <p:cNvPr id="5" name="TextBox 4"/>
+          <p:cNvSpPr txBox="1"/>
           <p:nvPr/>
         </p:nvSpPr>
         <p:spPr>
           <a:xfrm>
-            <a:off x="6400800" y="1188720"/>
-            <a:ext cx="5029200" cy="4572000"/>
-          </a:xfrm>
-          <a:prstGeom prst="roundRect">
-            <a:avLst/>
-          </a:prstGeom>
-          <a:solidFill>
-            <a:srgbClr val="F8F9FA"/>
-          </a:solidFill>
-          <a:ln w="25400">
-            <a:solidFill>
-              <a:srgbClr val="1A73E8"/>
-            </a:solidFill>
-          </a:ln>
-        </p:spPr>
-        <p:style>
-          <a:lnRef idx="1">
-            <a:schemeClr val="accent1"/>
-          </a:lnRef>
-          <a:fillRef idx="3">
-            <a:schemeClr val="accent1"/>
-          </a:fillRef>
-          <a:effectRef idx="2">
-            <a:schemeClr val="accent1"/>
-          </a:effectRef>
-          <a:fontRef idx="minor">
-            <a:schemeClr val="lt1"/>
-          </a:fontRef>
-        </p:style>
-        <p:txBody>
-          <a:bodyPr rtlCol="0" anchor="ctr"/>
-          <a:lstStyle/>
-          <a:p>
-            <a:pPr algn="ctr"/>
-          </a:p>
-        </p:txBody>
-      </p:sp>
-      <p:sp>
-        <p:nvSpPr>
-          <p:cNvPr id="7" name="TextBox 6"/>
-          <p:cNvSpPr txBox="1"/>
-          <p:nvPr/>
-        </p:nvSpPr>
-        <p:spPr>
-          <a:xfrm>
-            <a:off x="6766560" y="1371600"/>
-            <a:ext cx="4389120" cy="457200"/>
+            <a:off x="1371600" y="4114800"/>
+            <a:ext cx="9144000" cy="457200"/>
           </a:xfrm>
           <a:prstGeom prst="rect">
             <a:avLst/>
@@ -7421,30 +7561,30 @@
           </a:bodyPr>
           <a:lstStyle/>
           <a:p>
-            <a:pPr algn="l">
-              <a:defRPr sz="2000" b="1">
-                <a:solidFill>
-                  <a:srgbClr val="1A73E8"/>
-                </a:solidFill>
-                <a:latin typeface="Calibri"/>
-              </a:defRPr>
-            </a:pPr>
-            <a:r>
-              <a:t>🔜 Coming Next</a:t>
-            </a:r>
-          </a:p>
-        </p:txBody>
-      </p:sp>
-      <p:sp>
-        <p:nvSpPr>
-          <p:cNvPr id="8" name="TextBox 7"/>
+            <a:pPr algn="ctr">
+              <a:defRPr sz="2400" b="0">
+                <a:solidFill>
+                  <a:srgbClr val="5F6368"/>
+                </a:solidFill>
+                <a:latin typeface="Consolas"/>
+              </a:defRPr>
+            </a:pPr>
+            <a:r>
+              <a:t>npx f2g-telco init</a:t>
+            </a:r>
+          </a:p>
+        </p:txBody>
+      </p:sp>
+      <p:sp>
+        <p:nvSpPr>
+          <p:cNvPr id="6" name="TextBox 5"/>
           <p:cNvSpPr txBox="1"/>
           <p:nvPr/>
         </p:nvSpPr>
         <p:spPr>
           <a:xfrm>
-            <a:off x="6766560" y="2103120"/>
-            <a:ext cx="4389120" cy="4572000"/>
+            <a:off x="1371600" y="5029200"/>
+            <a:ext cx="9144000" cy="457200"/>
           </a:xfrm>
           <a:prstGeom prst="rect">
             <a:avLst/>
@@ -7457,142 +7597,30 @@
           </a:bodyPr>
           <a:lstStyle/>
           <a:p>
-            <a:pPr>
-              <a:spcAft>
-                <a:spcPts val="800"/>
-              </a:spcAft>
-              <a:defRPr sz="1500">
-                <a:solidFill>
-                  <a:srgbClr val="202020"/>
-                </a:solidFill>
-                <a:latin typeface="Calibri"/>
-              </a:defRPr>
-            </a:pPr>
-            <a:r>
-              <a:t>• Team profiles in F2G-Telco CLI</a:t>
-            </a:r>
-          </a:p>
-          <a:p>
-            <a:pPr>
-              <a:spcAft>
-                <a:spcPts val="800"/>
-              </a:spcAft>
-              <a:defRPr sz="1500">
-                <a:solidFill>
-                  <a:srgbClr val="202020"/>
-                </a:solidFill>
-                <a:latin typeface="Calibri"/>
-              </a:defRPr>
-            </a:pPr>
-            <a:r>
-              <a:t>• f2g-telco init --team &lt;name&gt;</a:t>
-            </a:r>
-          </a:p>
-          <a:p>
-            <a:pPr>
-              <a:spcAft>
-                <a:spcPts val="800"/>
-              </a:spcAft>
-              <a:defRPr sz="1500">
-                <a:solidFill>
-                  <a:srgbClr val="202020"/>
-                </a:solidFill>
-                <a:latin typeface="Calibri"/>
-              </a:defRPr>
-            </a:pPr>
-            <a:r>
-              <a:t>• Pre-configured shared keys</a:t>
-            </a:r>
-          </a:p>
-          <a:p>
-            <a:pPr>
-              <a:spcAft>
-                <a:spcPts val="800"/>
-              </a:spcAft>
-              <a:defRPr sz="1500">
-                <a:solidFill>
-                  <a:srgbClr val="202020"/>
-                </a:solidFill>
-                <a:latin typeface="Calibri"/>
-              </a:defRPr>
-            </a:pPr>
-            <a:r>
-              <a:t>• Role-based context visibility</a:t>
-            </a:r>
-          </a:p>
-          <a:p>
-            <a:pPr>
-              <a:spcAft>
-                <a:spcPts val="800"/>
-              </a:spcAft>
-              <a:defRPr sz="1500">
-                <a:solidFill>
-                  <a:srgbClr val="202020"/>
-                </a:solidFill>
-                <a:latin typeface="Calibri"/>
-              </a:defRPr>
-            </a:pPr>
-            <a:r>
-              <a:t>• Admin dashboard for team memory</a:t>
-            </a:r>
-          </a:p>
-          <a:p>
-            <a:pPr>
-              <a:spcAft>
-                <a:spcPts val="800"/>
-              </a:spcAft>
-              <a:defRPr sz="1500">
-                <a:solidFill>
-                  <a:srgbClr val="202020"/>
-                </a:solidFill>
-                <a:latin typeface="Calibri"/>
-              </a:defRPr>
-            </a:pPr>
-          </a:p>
-          <a:p>
-            <a:pPr>
-              <a:spcAft>
-                <a:spcPts val="800"/>
-              </a:spcAft>
-              <a:defRPr sz="1500">
-                <a:solidFill>
-                  <a:srgbClr val="202020"/>
-                </a:solidFill>
-                <a:latin typeface="Calibri"/>
-              </a:defRPr>
-            </a:pPr>
-            <a:r>
-              <a:t>One command to join the team's</a:t>
-            </a:r>
-          </a:p>
-          <a:p>
-            <a:pPr>
-              <a:spcAft>
-                <a:spcPts val="800"/>
-              </a:spcAft>
-              <a:defRPr sz="1500">
-                <a:solidFill>
-                  <a:srgbClr val="202020"/>
-                </a:solidFill>
-                <a:latin typeface="Calibri"/>
-              </a:defRPr>
-            </a:pPr>
-            <a:r>
-              <a:t>AI knowledge network.</a:t>
-            </a:r>
-          </a:p>
-        </p:txBody>
-      </p:sp>
-      <p:sp>
-        <p:nvSpPr>
-          <p:cNvPr id="9" name="TextBox 8"/>
+            <a:pPr algn="ctr">
+              <a:defRPr sz="1800" b="0">
+                <a:solidFill>
+                  <a:srgbClr val="4285F4"/>
+                </a:solidFill>
+                <a:latin typeface="Calibri"/>
+              </a:defRPr>
+            </a:pPr>
+            <a:r>
+              <a:t>github.com/suzannekouemou/f2g-telco</a:t>
+            </a:r>
+          </a:p>
+        </p:txBody>
+      </p:sp>
+      <p:sp>
+        <p:nvSpPr>
+          <p:cNvPr id="7" name="TextBox 6"/>
           <p:cNvSpPr txBox="1"/>
           <p:nvPr/>
         </p:nvSpPr>
         <p:spPr>
           <a:xfrm>
-            <a:off x="731520" y="5943600"/>
-            <a:ext cx="10058400" cy="457200"/>
+            <a:off x="1371600" y="5669280"/>
+            <a:ext cx="9144000" cy="457200"/>
           </a:xfrm>
           <a:prstGeom prst="rect">
             <a:avLst/>
@@ -7605,8 +7633,8 @@
           </a:bodyPr>
           <a:lstStyle/>
           <a:p>
-            <a:pPr algn="l">
-              <a:defRPr sz="1600" b="1">
+            <a:pPr algn="ctr">
+              <a:defRPr sz="1600" b="0">
                 <a:solidFill>
                   <a:srgbClr val="5F6368"/>
                 </a:solidFill>
@@ -7614,7 +7642,7 @@
               </a:defRPr>
             </a:pPr>
             <a:r>
-              <a:t>The infrastructure is ready. The shared context vision is a configuration change, not a rebuild.</a:t>
+              <a:t>MIT Licensed  •  Open Source  •  Free</a:t>
             </a:r>
           </a:p>
         </p:txBody>
@@ -7932,241 +7960,6 @@
           <a:chExt cx="0" cy="0"/>
         </a:xfrm>
       </p:grpSpPr>
-      <p:sp>
-        <p:nvSpPr>
-          <p:cNvPr id="2" name="TextBox 1"/>
-          <p:cNvSpPr txBox="1"/>
-          <p:nvPr/>
-        </p:nvSpPr>
-        <p:spPr>
-          <a:xfrm>
-            <a:off x="731520" y="365760"/>
-            <a:ext cx="10058400" cy="640080"/>
-          </a:xfrm>
-          <a:prstGeom prst="rect">
-            <a:avLst/>
-          </a:prstGeom>
-          <a:noFill/>
-        </p:spPr>
-        <p:txBody>
-          <a:bodyPr wrap="square">
-            <a:spAutoFit/>
-          </a:bodyPr>
-          <a:lstStyle/>
-          <a:p>
-            <a:pPr algn="l">
-              <a:defRPr sz="3200" b="1">
-                <a:solidFill>
-                  <a:srgbClr val="1A73E8"/>
-                </a:solidFill>
-                <a:latin typeface="Calibri"/>
-              </a:defRPr>
-            </a:pPr>
-            <a:r>
-              <a:t>Published on npm — Install Like an App</a:t>
-            </a:r>
-          </a:p>
-        </p:txBody>
-      </p:sp>
-      <p:sp>
-        <p:nvSpPr>
-          <p:cNvPr id="3" name="TextBox 2"/>
-          <p:cNvSpPr txBox="1"/>
-          <p:nvPr/>
-        </p:nvSpPr>
-        <p:spPr>
-          <a:xfrm>
-            <a:off x="731520" y="1188720"/>
-            <a:ext cx="5943600" cy="548640"/>
-          </a:xfrm>
-          <a:prstGeom prst="rect">
-            <a:avLst/>
-          </a:prstGeom>
-          <a:noFill/>
-        </p:spPr>
-        <p:txBody>
-          <a:bodyPr wrap="square">
-            <a:spAutoFit/>
-          </a:bodyPr>
-          <a:lstStyle/>
-          <a:p>
-            <a:pPr algn="l">
-              <a:defRPr sz="1800" b="0">
-                <a:solidFill>
-                  <a:srgbClr val="202020"/>
-                </a:solidFill>
-                <a:latin typeface="Calibri"/>
-              </a:defRPr>
-            </a:pPr>
-            <a:r>
-              <a:t>F2G-Telco is a published npm package. No cloning, no building.</a:t>
-            </a:r>
-          </a:p>
-        </p:txBody>
-      </p:sp>
-      <p:sp>
-        <p:nvSpPr>
-          <p:cNvPr id="4" name="TextBox 3"/>
-          <p:cNvSpPr txBox="1"/>
-          <p:nvPr/>
-        </p:nvSpPr>
-        <p:spPr>
-          <a:xfrm>
-            <a:off x="731520" y="1920240"/>
-            <a:ext cx="5943600" cy="4572000"/>
-          </a:xfrm>
-          <a:prstGeom prst="rect">
-            <a:avLst/>
-          </a:prstGeom>
-          <a:noFill/>
-        </p:spPr>
-        <p:txBody>
-          <a:bodyPr wrap="square">
-            <a:spAutoFit/>
-          </a:bodyPr>
-          <a:lstStyle/>
-          <a:p>
-            <a:pPr>
-              <a:spcAft>
-                <a:spcPts val="800"/>
-              </a:spcAft>
-              <a:defRPr sz="1700">
-                <a:solidFill>
-                  <a:srgbClr val="202020"/>
-                </a:solidFill>
-                <a:latin typeface="Calibri"/>
-              </a:defRPr>
-            </a:pPr>
-            <a:r>
-              <a:t>📦  Published at npmjs.com/package/f2g-telco</a:t>
-            </a:r>
-          </a:p>
-          <a:p>
-            <a:pPr>
-              <a:spcAft>
-                <a:spcPts val="800"/>
-              </a:spcAft>
-              <a:defRPr sz="1700">
-                <a:solidFill>
-                  <a:srgbClr val="202020"/>
-                </a:solidFill>
-                <a:latin typeface="Calibri"/>
-              </a:defRPr>
-            </a:pPr>
-            <a:r>
-              <a:t>⚡  Install: npx f2g-telco init — one command, like downloading an app</a:t>
-            </a:r>
-          </a:p>
-          <a:p>
-            <a:pPr>
-              <a:spcAft>
-                <a:spcPts val="800"/>
-              </a:spcAft>
-              <a:defRPr sz="1700">
-                <a:solidFill>
-                  <a:srgbClr val="202020"/>
-                </a:solidFill>
-                <a:latin typeface="Calibri"/>
-              </a:defRPr>
-            </a:pPr>
-            <a:r>
-              <a:t>🔄  Update: npx f2g-telco update — pulls latest registries, like a Play Store update</a:t>
-            </a:r>
-          </a:p>
-          <a:p>
-            <a:pPr>
-              <a:spcAft>
-                <a:spcPts val="800"/>
-              </a:spcAft>
-              <a:defRPr sz="1700">
-                <a:solidFill>
-                  <a:srgbClr val="202020"/>
-                </a:solidFill>
-                <a:latin typeface="Calibri"/>
-              </a:defRPr>
-            </a:pPr>
-            <a:r>
-              <a:t>🌍  Anyone with Node.js can use it — no special access needed</a:t>
-            </a:r>
-          </a:p>
-          <a:p>
-            <a:pPr>
-              <a:spcAft>
-                <a:spcPts val="800"/>
-              </a:spcAft>
-              <a:defRPr sz="1700">
-                <a:solidFill>
-                  <a:srgbClr val="202020"/>
-                </a:solidFill>
-                <a:latin typeface="Calibri"/>
-              </a:defRPr>
-            </a:pPr>
-            <a:r>
-              <a:t>🏗️  Actively maintained — CI on Node 18/20/22, semantic versioning</a:t>
-            </a:r>
-          </a:p>
-          <a:p>
-            <a:pPr>
-              <a:spcAft>
-                <a:spcPts val="800"/>
-              </a:spcAft>
-              <a:defRPr sz="1700">
-                <a:solidFill>
-                  <a:srgbClr val="202020"/>
-                </a:solidFill>
-                <a:latin typeface="Calibri"/>
-              </a:defRPr>
-            </a:pPr>
-            <a:r>
-              <a:t>📋  Current version: v0.1.3 (13 MCPs, 7 providers, 3 skill sources)</a:t>
-            </a:r>
-          </a:p>
-        </p:txBody>
-      </p:sp>
-      <p:sp>
-        <p:nvSpPr>
-          <p:cNvPr id="5" name="TextBox 4"/>
-          <p:cNvSpPr txBox="1"/>
-          <p:nvPr/>
-        </p:nvSpPr>
-        <p:spPr>
-          <a:xfrm>
-            <a:off x="731520" y="4754880"/>
-            <a:ext cx="5943600" cy="914400"/>
-          </a:xfrm>
-          <a:prstGeom prst="rect">
-            <a:avLst/>
-          </a:prstGeom>
-          <a:noFill/>
-        </p:spPr>
-        <p:txBody>
-          <a:bodyPr wrap="square">
-            <a:spAutoFit/>
-          </a:bodyPr>
-          <a:lstStyle/>
-          <a:p>
-            <a:pPr algn="l">
-              <a:defRPr sz="1600" b="1">
-                <a:solidFill>
-                  <a:srgbClr val="5F6368"/>
-                </a:solidFill>
-                <a:latin typeface="Calibri"/>
-              </a:defRPr>
-            </a:pPr>
-            <a:r>
-              <a:t>Think of it like an APK for your AI coding environment.</a:t>
-            </a:r>
-            <a:br/>
-            <a:r>
-              <a:t>Type one command → get a fully configured setup.</a:t>
-            </a:r>
-            <a:br/>
-            <a:r>
-              <a:t>Type another command → get the latest version.</a:t>
-            </a:r>
-          </a:p>
-        </p:txBody>
-      </p:sp>
       <p:pic>
         <p:nvPicPr>
           <p:cNvPr id="6" name="Picture 5" descr="update-flow.png"/>
@@ -8183,14 +7976,249 @@
         </p:blipFill>
         <p:spPr>
           <a:xfrm>
-            <a:off x="7132320" y="1371600"/>
-            <a:ext cx="4754880" cy="1294669"/>
+            <a:off x="5471545" y="874394"/>
+            <a:ext cx="6513666" cy="1773555"/>
           </a:xfrm>
           <a:prstGeom prst="rect">
             <a:avLst/>
           </a:prstGeom>
         </p:spPr>
       </p:pic>
+      <p:sp>
+        <p:nvSpPr>
+          <p:cNvPr id="2" name="TextBox 1"/>
+          <p:cNvSpPr txBox="1"/>
+          <p:nvPr/>
+        </p:nvSpPr>
+        <p:spPr>
+          <a:xfrm>
+            <a:off x="731520" y="365760"/>
+            <a:ext cx="10058400" cy="640080"/>
+          </a:xfrm>
+          <a:prstGeom prst="rect">
+            <a:avLst/>
+          </a:prstGeom>
+          <a:noFill/>
+        </p:spPr>
+        <p:txBody>
+          <a:bodyPr wrap="square">
+            <a:spAutoFit/>
+          </a:bodyPr>
+          <a:lstStyle/>
+          <a:p>
+            <a:pPr algn="l">
+              <a:defRPr sz="3200" b="1">
+                <a:solidFill>
+                  <a:srgbClr val="1A73E8"/>
+                </a:solidFill>
+                <a:latin typeface="Calibri"/>
+              </a:defRPr>
+            </a:pPr>
+            <a:r>
+              <a:t>Published on npm — Install Like an App</a:t>
+            </a:r>
+          </a:p>
+        </p:txBody>
+      </p:sp>
+      <p:sp>
+        <p:nvSpPr>
+          <p:cNvPr id="3" name="TextBox 2"/>
+          <p:cNvSpPr txBox="1"/>
+          <p:nvPr/>
+        </p:nvSpPr>
+        <p:spPr>
+          <a:xfrm>
+            <a:off x="731520" y="1188720"/>
+            <a:ext cx="5943600" cy="548640"/>
+          </a:xfrm>
+          <a:prstGeom prst="rect">
+            <a:avLst/>
+          </a:prstGeom>
+          <a:noFill/>
+        </p:spPr>
+        <p:txBody>
+          <a:bodyPr wrap="square">
+            <a:spAutoFit/>
+          </a:bodyPr>
+          <a:lstStyle/>
+          <a:p>
+            <a:pPr algn="l">
+              <a:defRPr sz="1800" b="0">
+                <a:solidFill>
+                  <a:srgbClr val="202020"/>
+                </a:solidFill>
+                <a:latin typeface="Calibri"/>
+              </a:defRPr>
+            </a:pPr>
+            <a:r>
+              <a:t>F2G-Telco is a published npm package. No cloning, no building.</a:t>
+            </a:r>
+          </a:p>
+        </p:txBody>
+      </p:sp>
+      <p:sp>
+        <p:nvSpPr>
+          <p:cNvPr id="4" name="TextBox 3"/>
+          <p:cNvSpPr txBox="1"/>
+          <p:nvPr/>
+        </p:nvSpPr>
+        <p:spPr>
+          <a:xfrm>
+            <a:off x="731520" y="1920240"/>
+            <a:ext cx="5943600" cy="4572000"/>
+          </a:xfrm>
+          <a:prstGeom prst="rect">
+            <a:avLst/>
+          </a:prstGeom>
+          <a:noFill/>
+        </p:spPr>
+        <p:txBody>
+          <a:bodyPr wrap="square">
+            <a:spAutoFit/>
+          </a:bodyPr>
+          <a:lstStyle/>
+          <a:p>
+            <a:pPr>
+              <a:spcAft>
+                <a:spcPts val="800"/>
+              </a:spcAft>
+              <a:defRPr sz="1700">
+                <a:solidFill>
+                  <a:srgbClr val="202020"/>
+                </a:solidFill>
+                <a:latin typeface="Calibri"/>
+              </a:defRPr>
+            </a:pPr>
+            <a:r>
+              <a:t>📦  Published at npmjs.com/package/f2g-telco</a:t>
+            </a:r>
+          </a:p>
+          <a:p>
+            <a:pPr>
+              <a:spcAft>
+                <a:spcPts val="800"/>
+              </a:spcAft>
+              <a:defRPr sz="1700">
+                <a:solidFill>
+                  <a:srgbClr val="202020"/>
+                </a:solidFill>
+                <a:latin typeface="Calibri"/>
+              </a:defRPr>
+            </a:pPr>
+            <a:r>
+              <a:t>⚡  Install: npx f2g-telco init — one command, like downloading an app</a:t>
+            </a:r>
+          </a:p>
+          <a:p>
+            <a:pPr>
+              <a:spcAft>
+                <a:spcPts val="800"/>
+              </a:spcAft>
+              <a:defRPr sz="1700">
+                <a:solidFill>
+                  <a:srgbClr val="202020"/>
+                </a:solidFill>
+                <a:latin typeface="Calibri"/>
+              </a:defRPr>
+            </a:pPr>
+            <a:r>
+              <a:t>🔄  Update: npx f2g-telco update — pulls latest registries, like a Play Store update</a:t>
+            </a:r>
+          </a:p>
+          <a:p>
+            <a:pPr>
+              <a:spcAft>
+                <a:spcPts val="800"/>
+              </a:spcAft>
+              <a:defRPr sz="1700">
+                <a:solidFill>
+                  <a:srgbClr val="202020"/>
+                </a:solidFill>
+                <a:latin typeface="Calibri"/>
+              </a:defRPr>
+            </a:pPr>
+            <a:r>
+              <a:t>🌍  Anyone with Node.js can use it — no special access needed</a:t>
+            </a:r>
+          </a:p>
+          <a:p>
+            <a:pPr>
+              <a:spcAft>
+                <a:spcPts val="800"/>
+              </a:spcAft>
+              <a:defRPr sz="1700">
+                <a:solidFill>
+                  <a:srgbClr val="202020"/>
+                </a:solidFill>
+                <a:latin typeface="Calibri"/>
+              </a:defRPr>
+            </a:pPr>
+            <a:r>
+              <a:t>🏗️  Actively maintained — CI on Node 18/20/22, semantic versioning</a:t>
+            </a:r>
+          </a:p>
+          <a:p>
+            <a:pPr>
+              <a:spcAft>
+                <a:spcPts val="800"/>
+              </a:spcAft>
+              <a:defRPr sz="1700">
+                <a:solidFill>
+                  <a:srgbClr val="202020"/>
+                </a:solidFill>
+                <a:latin typeface="Calibri"/>
+              </a:defRPr>
+            </a:pPr>
+            <a:r>
+              <a:t>📋  Current version: v0.1.3 (13 MCPs, 7 providers, 3 skill sources)</a:t>
+            </a:r>
+          </a:p>
+        </p:txBody>
+      </p:sp>
+      <p:sp>
+        <p:nvSpPr>
+          <p:cNvPr id="5" name="TextBox 4"/>
+          <p:cNvSpPr txBox="1"/>
+          <p:nvPr/>
+        </p:nvSpPr>
+        <p:spPr>
+          <a:xfrm>
+            <a:off x="731520" y="4754880"/>
+            <a:ext cx="5943600" cy="914400"/>
+          </a:xfrm>
+          <a:prstGeom prst="rect">
+            <a:avLst/>
+          </a:prstGeom>
+          <a:noFill/>
+        </p:spPr>
+        <p:txBody>
+          <a:bodyPr wrap="square">
+            <a:spAutoFit/>
+          </a:bodyPr>
+          <a:lstStyle/>
+          <a:p>
+            <a:pPr algn="l">
+              <a:defRPr sz="1600" b="1">
+                <a:solidFill>
+                  <a:srgbClr val="5F6368"/>
+                </a:solidFill>
+                <a:latin typeface="Calibri"/>
+              </a:defRPr>
+            </a:pPr>
+            <a:r>
+              <a:t>Think of it like an APK for your AI coding environment.</a:t>
+            </a:r>
+            <a:br/>
+            <a:r>
+              <a:t>Type one command → get a fully configured setup.</a:t>
+            </a:r>
+            <a:br/>
+            <a:r>
+              <a:t>Type another command → get the latest version.</a:t>
+            </a:r>
+          </a:p>
+        </p:txBody>
+      </p:sp>
     </p:spTree>
   </p:cSld>
   <p:clrMapOvr>

</xml_diff>